<commit_message>
Polished student deck: live lecture hyperlinks, rebalanced whitespace, appendix B redesign
Co-authored-by: arena-agent <297053741+arena-agent@users.noreply.github.com>
</commit_message>
<xml_diff>
--- a/Zenith-V_Launch_Decision_JGaneshKumarReddy_23BDS024.pptx
+++ b/Zenith-V_Launch_Decision_JGaneshKumarReddy_23BDS024.pptx
@@ -4792,42 +4792,223 @@
         <p:spPr>
           <a:xfrm>
             <a:off x="877824" y="5285232"/>
-            <a:ext cx="10436047" cy="329184"/>
-          </a:xfrm>
-          <a:prstGeom prst="rect">
-            <a:avLst/>
-          </a:prstGeom>
-          <a:noFill/>
-        </p:spPr>
-        <p:txBody>
-          <a:bodyPr wrap="square" lIns="0" rIns="0" tIns="0" bIns="0" anchor="t">
-            <a:noAutofit/>
-          </a:bodyPr>
-          <a:lstStyle/>
-          <a:p>
-            <a:pPr algn="l">
-              <a:lnSpc>
-                <a:spcPct val="135000"/>
-              </a:lnSpc>
-            </a:pPr>
-            <a:r>
-              <a:rPr sz="940" b="1" i="0">
+            <a:ext cx="658368" cy="219456"/>
+          </a:xfrm>
+          <a:prstGeom prst="rect">
+            <a:avLst/>
+          </a:prstGeom>
+          <a:noFill/>
+        </p:spPr>
+        <p:txBody>
+          <a:bodyPr wrap="square" lIns="0" rIns="0" tIns="0" bIns="0" anchor="t">
+            <a:noAutofit/>
+          </a:bodyPr>
+          <a:lstStyle/>
+          <a:p>
+            <a:pPr algn="l">
+              <a:lnSpc>
+                <a:spcPct val="130000"/>
+              </a:lnSpc>
+            </a:pPr>
+            <a:r>
+              <a:rPr sz="900" b="1" i="0">
                 <a:solidFill>
                   <a:srgbClr val="12263F"/>
                 </a:solidFill>
                 <a:latin typeface="Calibri"/>
-              </a:rPr>
-              <a:t>Session 5 </a:t>
-            </a:r>
+                <a:hlinkClick r:id="rId3"/>
+              </a:rPr>
+              <a:t>Session 5</a:t>
+            </a:r>
+          </a:p>
+        </p:txBody>
+      </p:sp>
+      <p:sp>
+        <p:nvSpPr>
+          <p:cNvPr id="20" name="TextBox 19"/>
+          <p:cNvSpPr txBox="1"/>
+          <p:nvPr/>
+        </p:nvSpPr>
+        <p:spPr>
+          <a:xfrm>
+            <a:off x="1554480" y="5285232"/>
+            <a:ext cx="858139" cy="219456"/>
+          </a:xfrm>
+          <a:prstGeom prst="rect">
+            <a:avLst/>
+          </a:prstGeom>
+          <a:noFill/>
+        </p:spPr>
+        <p:txBody>
+          <a:bodyPr wrap="square" lIns="0" rIns="0" tIns="0" bIns="0" anchor="t">
+            <a:noAutofit/>
+          </a:bodyPr>
+          <a:lstStyle/>
+          <a:p>
+            <a:pPr algn="l">
+              <a:lnSpc>
+                <a:spcPct val="130000"/>
+              </a:lnSpc>
+            </a:pPr>
+            <a:r>
+              <a:rPr sz="900" b="0" i="0">
+                <a:solidFill>
+                  <a:srgbClr val="44546A"/>
+                </a:solidFill>
+                <a:latin typeface="Calibri"/>
+                <a:hlinkClick r:id="rId3"/>
+              </a:rPr>
+              <a:t>Pricing Strategies</a:t>
+            </a:r>
+          </a:p>
+        </p:txBody>
+      </p:sp>
+      <p:sp>
+        <p:nvSpPr>
+          <p:cNvPr id="21" name="TextBox 20"/>
+          <p:cNvSpPr txBox="1"/>
+          <p:nvPr/>
+        </p:nvSpPr>
+        <p:spPr>
+          <a:xfrm>
+            <a:off x="2449195" y="5285232"/>
+            <a:ext cx="274320" cy="219456"/>
+          </a:xfrm>
+          <a:prstGeom prst="rect">
+            <a:avLst/>
+          </a:prstGeom>
+          <a:noFill/>
+        </p:spPr>
+        <p:txBody>
+          <a:bodyPr wrap="square" lIns="0" rIns="0" tIns="0" bIns="0" anchor="t">
+            <a:noAutofit/>
+          </a:bodyPr>
+          <a:lstStyle/>
+          <a:p>
+            <a:pPr algn="l">
+              <a:lnSpc>
+                <a:spcPct val="130000"/>
+              </a:lnSpc>
+            </a:pPr>
             <a:r>
               <a:rPr sz="940" b="0" i="0">
                 <a:solidFill>
+                  <a:srgbClr val="C9DCF0"/>
+                </a:solidFill>
+                <a:latin typeface="Calibri"/>
+              </a:rPr>
+              <a:t>·</a:t>
+            </a:r>
+          </a:p>
+        </p:txBody>
+      </p:sp>
+      <p:sp>
+        <p:nvSpPr>
+          <p:cNvPr id="22" name="TextBox 21"/>
+          <p:cNvSpPr txBox="1"/>
+          <p:nvPr/>
+        </p:nvSpPr>
+        <p:spPr>
+          <a:xfrm>
+            <a:off x="2723515" y="5285232"/>
+            <a:ext cx="658368" cy="219456"/>
+          </a:xfrm>
+          <a:prstGeom prst="rect">
+            <a:avLst/>
+          </a:prstGeom>
+          <a:noFill/>
+        </p:spPr>
+        <p:txBody>
+          <a:bodyPr wrap="square" lIns="0" rIns="0" tIns="0" bIns="0" anchor="t">
+            <a:noAutofit/>
+          </a:bodyPr>
+          <a:lstStyle/>
+          <a:p>
+            <a:pPr algn="l">
+              <a:lnSpc>
+                <a:spcPct val="130000"/>
+              </a:lnSpc>
+            </a:pPr>
+            <a:r>
+              <a:rPr sz="900" b="1" i="0">
+                <a:solidFill>
+                  <a:srgbClr val="12263F"/>
+                </a:solidFill>
+                <a:latin typeface="Calibri"/>
+                <a:hlinkClick r:id="rId4"/>
+              </a:rPr>
+              <a:t>Session 6</a:t>
+            </a:r>
+          </a:p>
+        </p:txBody>
+      </p:sp>
+      <p:sp>
+        <p:nvSpPr>
+          <p:cNvPr id="23" name="TextBox 22"/>
+          <p:cNvSpPr txBox="1"/>
+          <p:nvPr/>
+        </p:nvSpPr>
+        <p:spPr>
+          <a:xfrm>
+            <a:off x="3400171" y="5285232"/>
+            <a:ext cx="315214" cy="219456"/>
+          </a:xfrm>
+          <a:prstGeom prst="rect">
+            <a:avLst/>
+          </a:prstGeom>
+          <a:noFill/>
+        </p:spPr>
+        <p:txBody>
+          <a:bodyPr wrap="square" lIns="0" rIns="0" tIns="0" bIns="0" anchor="t">
+            <a:noAutofit/>
+          </a:bodyPr>
+          <a:lstStyle/>
+          <a:p>
+            <a:pPr algn="l">
+              <a:lnSpc>
+                <a:spcPct val="130000"/>
+              </a:lnSpc>
+            </a:pPr>
+            <a:r>
+              <a:rPr sz="900" b="0" i="0">
+                <a:solidFill>
                   <a:srgbClr val="44546A"/>
                 </a:solidFill>
                 <a:latin typeface="Calibri"/>
-              </a:rPr>
-              <a:t>Pricing Strategies</a:t>
-            </a:r>
+                <a:hlinkClick r:id="rId4"/>
+              </a:rPr>
+              <a:t>Profit</a:t>
+            </a:r>
+          </a:p>
+        </p:txBody>
+      </p:sp>
+      <p:sp>
+        <p:nvSpPr>
+          <p:cNvPr id="24" name="TextBox 23"/>
+          <p:cNvSpPr txBox="1"/>
+          <p:nvPr/>
+        </p:nvSpPr>
+        <p:spPr>
+          <a:xfrm>
+            <a:off x="3751961" y="5285232"/>
+            <a:ext cx="274320" cy="219456"/>
+          </a:xfrm>
+          <a:prstGeom prst="rect">
+            <a:avLst/>
+          </a:prstGeom>
+          <a:noFill/>
+        </p:spPr>
+        <p:txBody>
+          <a:bodyPr wrap="square" lIns="0" rIns="0" tIns="0" bIns="0" anchor="t">
+            <a:noAutofit/>
+          </a:bodyPr>
+          <a:lstStyle/>
+          <a:p>
+            <a:pPr algn="l">
+              <a:lnSpc>
+                <a:spcPct val="130000"/>
+              </a:lnSpc>
+            </a:pPr>
             <a:r>
               <a:rPr sz="940" b="0" i="0">
                 <a:solidFill>
@@ -4835,26 +5016,237 @@
                 </a:solidFill>
                 <a:latin typeface="Calibri"/>
               </a:rPr>
-              <a:t>   ·   </a:t>
-            </a:r>
-            <a:r>
-              <a:rPr sz="940" b="1" i="0">
+              <a:t>·</a:t>
+            </a:r>
+          </a:p>
+        </p:txBody>
+      </p:sp>
+      <p:sp>
+        <p:nvSpPr>
+          <p:cNvPr id="25" name="TextBox 24"/>
+          <p:cNvSpPr txBox="1"/>
+          <p:nvPr/>
+        </p:nvSpPr>
+        <p:spPr>
+          <a:xfrm>
+            <a:off x="4026281" y="5285232"/>
+            <a:ext cx="658368" cy="219456"/>
+          </a:xfrm>
+          <a:prstGeom prst="rect">
+            <a:avLst/>
+          </a:prstGeom>
+          <a:noFill/>
+        </p:spPr>
+        <p:txBody>
+          <a:bodyPr wrap="square" lIns="0" rIns="0" tIns="0" bIns="0" anchor="t">
+            <a:noAutofit/>
+          </a:bodyPr>
+          <a:lstStyle/>
+          <a:p>
+            <a:pPr algn="l">
+              <a:lnSpc>
+                <a:spcPct val="130000"/>
+              </a:lnSpc>
+            </a:pPr>
+            <a:r>
+              <a:rPr sz="900" b="1" i="0">
                 <a:solidFill>
                   <a:srgbClr val="12263F"/>
                 </a:solidFill>
                 <a:latin typeface="Calibri"/>
-              </a:rPr>
-              <a:t>Session 6 </a:t>
-            </a:r>
+                <a:hlinkClick r:id="rId5"/>
+              </a:rPr>
+              <a:t>Session 7</a:t>
+            </a:r>
+          </a:p>
+        </p:txBody>
+      </p:sp>
+      <p:sp>
+        <p:nvSpPr>
+          <p:cNvPr id="26" name="TextBox 25"/>
+          <p:cNvSpPr txBox="1"/>
+          <p:nvPr/>
+        </p:nvSpPr>
+        <p:spPr>
+          <a:xfrm>
+            <a:off x="4702937" y="5285232"/>
+            <a:ext cx="683514" cy="219456"/>
+          </a:xfrm>
+          <a:prstGeom prst="rect">
+            <a:avLst/>
+          </a:prstGeom>
+          <a:noFill/>
+        </p:spPr>
+        <p:txBody>
+          <a:bodyPr wrap="square" lIns="0" rIns="0" tIns="0" bIns="0" anchor="t">
+            <a:noAutofit/>
+          </a:bodyPr>
+          <a:lstStyle/>
+          <a:p>
+            <a:pPr algn="l">
+              <a:lnSpc>
+                <a:spcPct val="130000"/>
+              </a:lnSpc>
+            </a:pPr>
+            <a:r>
+              <a:rPr sz="900" b="0" i="0">
+                <a:solidFill>
+                  <a:srgbClr val="44546A"/>
+                </a:solidFill>
+                <a:latin typeface="Calibri"/>
+                <a:hlinkClick r:id="rId5"/>
+              </a:rPr>
+              <a:t>Game Theory</a:t>
+            </a:r>
+          </a:p>
+        </p:txBody>
+      </p:sp>
+      <p:sp>
+        <p:nvSpPr>
+          <p:cNvPr id="27" name="TextBox 26"/>
+          <p:cNvSpPr txBox="1"/>
+          <p:nvPr/>
+        </p:nvSpPr>
+        <p:spPr>
+          <a:xfrm>
+            <a:off x="5423027" y="5285232"/>
+            <a:ext cx="274320" cy="219456"/>
+          </a:xfrm>
+          <a:prstGeom prst="rect">
+            <a:avLst/>
+          </a:prstGeom>
+          <a:noFill/>
+        </p:spPr>
+        <p:txBody>
+          <a:bodyPr wrap="square" lIns="0" rIns="0" tIns="0" bIns="0" anchor="t">
+            <a:noAutofit/>
+          </a:bodyPr>
+          <a:lstStyle/>
+          <a:p>
+            <a:pPr algn="l">
+              <a:lnSpc>
+                <a:spcPct val="130000"/>
+              </a:lnSpc>
+            </a:pPr>
             <a:r>
               <a:rPr sz="940" b="0" i="0">
                 <a:solidFill>
+                  <a:srgbClr val="C9DCF0"/>
+                </a:solidFill>
+                <a:latin typeface="Calibri"/>
+              </a:rPr>
+              <a:t>·</a:t>
+            </a:r>
+          </a:p>
+        </p:txBody>
+      </p:sp>
+      <p:sp>
+        <p:nvSpPr>
+          <p:cNvPr id="28" name="TextBox 27"/>
+          <p:cNvSpPr txBox="1"/>
+          <p:nvPr/>
+        </p:nvSpPr>
+        <p:spPr>
+          <a:xfrm>
+            <a:off x="5697347" y="5285232"/>
+            <a:ext cx="658368" cy="219456"/>
+          </a:xfrm>
+          <a:prstGeom prst="rect">
+            <a:avLst/>
+          </a:prstGeom>
+          <a:noFill/>
+        </p:spPr>
+        <p:txBody>
+          <a:bodyPr wrap="square" lIns="0" rIns="0" tIns="0" bIns="0" anchor="t">
+            <a:noAutofit/>
+          </a:bodyPr>
+          <a:lstStyle/>
+          <a:p>
+            <a:pPr algn="l">
+              <a:lnSpc>
+                <a:spcPct val="130000"/>
+              </a:lnSpc>
+            </a:pPr>
+            <a:r>
+              <a:rPr sz="900" b="1" i="0">
+                <a:solidFill>
+                  <a:srgbClr val="12263F"/>
+                </a:solidFill>
+                <a:latin typeface="Calibri"/>
+                <a:hlinkClick r:id="rId6"/>
+              </a:rPr>
+              <a:t>Session 8</a:t>
+            </a:r>
+          </a:p>
+        </p:txBody>
+      </p:sp>
+      <p:sp>
+        <p:nvSpPr>
+          <p:cNvPr id="29" name="TextBox 28"/>
+          <p:cNvSpPr txBox="1"/>
+          <p:nvPr/>
+        </p:nvSpPr>
+        <p:spPr>
+          <a:xfrm>
+            <a:off x="6374003" y="5285232"/>
+            <a:ext cx="239014" cy="219456"/>
+          </a:xfrm>
+          <a:prstGeom prst="rect">
+            <a:avLst/>
+          </a:prstGeom>
+          <a:noFill/>
+        </p:spPr>
+        <p:txBody>
+          <a:bodyPr wrap="square" lIns="0" rIns="0" tIns="0" bIns="0" anchor="t">
+            <a:noAutofit/>
+          </a:bodyPr>
+          <a:lstStyle/>
+          <a:p>
+            <a:pPr algn="l">
+              <a:lnSpc>
+                <a:spcPct val="130000"/>
+              </a:lnSpc>
+            </a:pPr>
+            <a:r>
+              <a:rPr sz="900" b="0" i="0">
+                <a:solidFill>
                   <a:srgbClr val="44546A"/>
                 </a:solidFill>
                 <a:latin typeface="Calibri"/>
-              </a:rPr>
-              <a:t>Profit</a:t>
-            </a:r>
+                <a:hlinkClick r:id="rId6"/>
+              </a:rPr>
+              <a:t>Risk</a:t>
+            </a:r>
+          </a:p>
+        </p:txBody>
+      </p:sp>
+      <p:sp>
+        <p:nvSpPr>
+          <p:cNvPr id="30" name="TextBox 29"/>
+          <p:cNvSpPr txBox="1"/>
+          <p:nvPr/>
+        </p:nvSpPr>
+        <p:spPr>
+          <a:xfrm>
+            <a:off x="6649593" y="5285232"/>
+            <a:ext cx="274320" cy="219456"/>
+          </a:xfrm>
+          <a:prstGeom prst="rect">
+            <a:avLst/>
+          </a:prstGeom>
+          <a:noFill/>
+        </p:spPr>
+        <p:txBody>
+          <a:bodyPr wrap="square" lIns="0" rIns="0" tIns="0" bIns="0" anchor="t">
+            <a:noAutofit/>
+          </a:bodyPr>
+          <a:lstStyle/>
+          <a:p>
+            <a:pPr algn="l">
+              <a:lnSpc>
+                <a:spcPct val="130000"/>
+              </a:lnSpc>
+            </a:pPr>
             <a:r>
               <a:rPr sz="940" b="0" i="0">
                 <a:solidFill>
@@ -4862,77 +5254,85 @@
                 </a:solidFill>
                 <a:latin typeface="Calibri"/>
               </a:rPr>
-              <a:t>   ·   </a:t>
-            </a:r>
-            <a:r>
-              <a:rPr sz="940" b="1" i="0">
+              <a:t>·</a:t>
+            </a:r>
+          </a:p>
+        </p:txBody>
+      </p:sp>
+      <p:sp>
+        <p:nvSpPr>
+          <p:cNvPr id="31" name="TextBox 30"/>
+          <p:cNvSpPr txBox="1"/>
+          <p:nvPr/>
+        </p:nvSpPr>
+        <p:spPr>
+          <a:xfrm>
+            <a:off x="6923913" y="5285232"/>
+            <a:ext cx="658368" cy="219456"/>
+          </a:xfrm>
+          <a:prstGeom prst="rect">
+            <a:avLst/>
+          </a:prstGeom>
+          <a:noFill/>
+        </p:spPr>
+        <p:txBody>
+          <a:bodyPr wrap="square" lIns="0" rIns="0" tIns="0" bIns="0" anchor="t">
+            <a:noAutofit/>
+          </a:bodyPr>
+          <a:lstStyle/>
+          <a:p>
+            <a:pPr algn="l">
+              <a:lnSpc>
+                <a:spcPct val="130000"/>
+              </a:lnSpc>
+            </a:pPr>
+            <a:r>
+              <a:rPr sz="900" b="1" i="0">
                 <a:solidFill>
                   <a:srgbClr val="12263F"/>
                 </a:solidFill>
                 <a:latin typeface="Calibri"/>
-              </a:rPr>
-              <a:t>Session 7 </a:t>
-            </a:r>
-            <a:r>
-              <a:rPr sz="940" b="0" i="0">
+                <a:hlinkClick r:id="rId7"/>
+              </a:rPr>
+              <a:t>Session 9</a:t>
+            </a:r>
+          </a:p>
+        </p:txBody>
+      </p:sp>
+      <p:sp>
+        <p:nvSpPr>
+          <p:cNvPr id="32" name="TextBox 31"/>
+          <p:cNvSpPr txBox="1"/>
+          <p:nvPr/>
+        </p:nvSpPr>
+        <p:spPr>
+          <a:xfrm>
+            <a:off x="7600569" y="5285232"/>
+            <a:ext cx="1547114" cy="219456"/>
+          </a:xfrm>
+          <a:prstGeom prst="rect">
+            <a:avLst/>
+          </a:prstGeom>
+          <a:noFill/>
+        </p:spPr>
+        <p:txBody>
+          <a:bodyPr wrap="square" lIns="0" rIns="0" tIns="0" bIns="0" anchor="t">
+            <a:noAutofit/>
+          </a:bodyPr>
+          <a:lstStyle/>
+          <a:p>
+            <a:pPr algn="l">
+              <a:lnSpc>
+                <a:spcPct val="130000"/>
+              </a:lnSpc>
+            </a:pPr>
+            <a:r>
+              <a:rPr sz="900" b="0" i="0">
                 <a:solidFill>
                   <a:srgbClr val="44546A"/>
                 </a:solidFill>
                 <a:latin typeface="Calibri"/>
-              </a:rPr>
-              <a:t>Game Theory</a:t>
-            </a:r>
-            <a:r>
-              <a:rPr sz="940" b="0" i="0">
-                <a:solidFill>
-                  <a:srgbClr val="C9DCF0"/>
-                </a:solidFill>
-                <a:latin typeface="Calibri"/>
-              </a:rPr>
-              <a:t>   ·   </a:t>
-            </a:r>
-            <a:r>
-              <a:rPr sz="940" b="1" i="0">
-                <a:solidFill>
-                  <a:srgbClr val="12263F"/>
-                </a:solidFill>
-                <a:latin typeface="Calibri"/>
-              </a:rPr>
-              <a:t>Session 8 </a:t>
-            </a:r>
-            <a:r>
-              <a:rPr sz="940" b="0" i="0">
-                <a:solidFill>
-                  <a:srgbClr val="44546A"/>
-                </a:solidFill>
-                <a:latin typeface="Calibri"/>
-              </a:rPr>
-              <a:t>Risk</a:t>
-            </a:r>
-            <a:r>
-              <a:rPr sz="940" b="0" i="0">
-                <a:solidFill>
-                  <a:srgbClr val="C9DCF0"/>
-                </a:solidFill>
-                <a:latin typeface="Calibri"/>
-              </a:rPr>
-              <a:t>   ·   </a:t>
-            </a:r>
-            <a:r>
-              <a:rPr sz="940" b="1" i="0">
-                <a:solidFill>
-                  <a:srgbClr val="12263F"/>
-                </a:solidFill>
-                <a:latin typeface="Calibri"/>
-              </a:rPr>
-              <a:t>Session 9 </a:t>
-            </a:r>
-            <a:r>
-              <a:rPr sz="940" b="0" i="0">
-                <a:solidFill>
-                  <a:srgbClr val="44546A"/>
-                </a:solidFill>
-                <a:latin typeface="Calibri"/>
+                <a:hlinkClick r:id="rId7"/>
               </a:rPr>
               <a:t>Capital Budgeting &amp; Fiscal Policy</a:t>
             </a:r>
@@ -4941,7 +5341,7 @@
       </p:sp>
       <p:sp>
         <p:nvSpPr>
-          <p:cNvPr id="20" name="TextBox 19"/>
+          <p:cNvPr id="33" name="TextBox 32"/>
           <p:cNvSpPr txBox="1"/>
           <p:nvPr/>
         </p:nvSpPr>
@@ -4980,7 +5380,7 @@
       </p:sp>
       <p:cxnSp>
         <p:nvCxnSpPr>
-          <p:cNvPr id="21" name="Connector 20"/>
+          <p:cNvPr id="34" name="Connector 33"/>
           <p:cNvCxnSpPr/>
           <p:nvPr/>
         </p:nvCxnSpPr>
@@ -5015,7 +5415,7 @@
       </p:cxnSp>
       <p:sp>
         <p:nvSpPr>
-          <p:cNvPr id="22" name="TextBox 21"/>
+          <p:cNvPr id="35" name="TextBox 34"/>
           <p:cNvSpPr txBox="1"/>
           <p:nvPr/>
         </p:nvSpPr>
@@ -5054,7 +5454,7 @@
       </p:sp>
       <p:sp>
         <p:nvSpPr>
-          <p:cNvPr id="23" name="TextBox 22"/>
+          <p:cNvPr id="36" name="TextBox 35"/>
           <p:cNvSpPr txBox="1"/>
           <p:nvPr/>
         </p:nvSpPr>
@@ -5093,7 +5493,7 @@
       </p:sp>
       <p:sp>
         <p:nvSpPr>
-          <p:cNvPr id="24" name="TextBox 23"/>
+          <p:cNvPr id="37" name="TextBox 36"/>
           <p:cNvSpPr txBox="1"/>
           <p:nvPr/>
         </p:nvSpPr>
@@ -5132,7 +5532,7 @@
       </p:sp>
       <p:sp>
         <p:nvSpPr>
-          <p:cNvPr id="25" name="TextBox 24"/>
+          <p:cNvPr id="38" name="TextBox 37"/>
           <p:cNvSpPr txBox="1"/>
           <p:nvPr/>
         </p:nvSpPr>
@@ -5240,7 +5640,7 @@
         <p:spPr>
           <a:xfrm>
             <a:off x="658368" y="310896"/>
-            <a:ext cx="6035040" cy="182880"/>
+            <a:ext cx="5669280" cy="182880"/>
           </a:xfrm>
           <a:prstGeom prst="rect">
             <a:avLst/>
@@ -5278,8 +5678,8 @@
         </p:nvSpPr>
         <p:spPr>
           <a:xfrm>
-            <a:off x="7327087" y="310896"/>
-            <a:ext cx="4206240" cy="182880"/>
+            <a:off x="6595567" y="310896"/>
+            <a:ext cx="4937760" cy="182880"/>
           </a:xfrm>
           <a:prstGeom prst="rect">
             <a:avLst/>
@@ -5300,9 +5700,10 @@
             <a:r>
               <a:rPr sz="760" b="1" i="0" spc="110">
                 <a:solidFill>
-                  <a:srgbClr val="7B8B9E"/>
-                </a:solidFill>
-                <a:latin typeface="Calibri"/>
+                  <a:srgbClr val="2B6CB0"/>
+                </a:solidFill>
+                <a:latin typeface="Calibri"/>
+                <a:hlinkClick r:id="rId2"/>
               </a:rPr>
               <a:t>LECTURE LINK · SESSION 7: GAME THEORY</a:t>
             </a:r>
@@ -5509,26 +5910,26 @@
         <p:spPr>
           <a:xfrm>
             <a:off x="1042416" y="1700793"/>
-            <a:ext cx="5422392" cy="323332"/>
-          </a:xfrm>
-          <a:prstGeom prst="rect">
-            <a:avLst/>
-          </a:prstGeom>
-          <a:noFill/>
-        </p:spPr>
-        <p:txBody>
-          <a:bodyPr wrap="square" lIns="0" rIns="0" tIns="0" bIns="0" anchor="t">
-            <a:noAutofit/>
-          </a:bodyPr>
-          <a:lstStyle/>
-          <a:p>
-            <a:pPr algn="l">
-              <a:lnSpc>
-                <a:spcPct val="130000"/>
-              </a:lnSpc>
-            </a:pPr>
-            <a:r>
-              <a:rPr sz="960" b="0" i="0">
+            <a:ext cx="5422392" cy="338566"/>
+          </a:xfrm>
+          <a:prstGeom prst="rect">
+            <a:avLst/>
+          </a:prstGeom>
+          <a:noFill/>
+        </p:spPr>
+        <p:txBody>
+          <a:bodyPr wrap="square" lIns="0" rIns="0" tIns="0" bIns="0" anchor="t">
+            <a:noAutofit/>
+          </a:bodyPr>
+          <a:lstStyle/>
+          <a:p>
+            <a:pPr algn="l">
+              <a:lnSpc>
+                <a:spcPct val="132000"/>
+              </a:lnSpc>
+            </a:pPr>
+            <a:r>
+              <a:rPr sz="990" b="0" i="0">
                 <a:solidFill>
                   <a:srgbClr val="44546A"/>
                 </a:solidFill>
@@ -5547,7 +5948,7 @@
         </p:nvCxnSpPr>
         <p:spPr>
           <a:xfrm>
-            <a:off x="658368" y="2161285"/>
+            <a:off x="658368" y="2240527"/>
             <a:ext cx="5623560" cy="0"/>
           </a:xfrm>
           <a:prstGeom prst="line">
@@ -5582,7 +5983,7 @@
         </p:nvSpPr>
         <p:spPr>
           <a:xfrm>
-            <a:off x="658368" y="2335021"/>
+            <a:off x="658368" y="2496559"/>
             <a:ext cx="310896" cy="237744"/>
           </a:xfrm>
           <a:prstGeom prst="rect">
@@ -5621,7 +6022,7 @@
         </p:nvSpPr>
         <p:spPr>
           <a:xfrm>
-            <a:off x="1042416" y="2298445"/>
+            <a:off x="1042416" y="2459983"/>
             <a:ext cx="5422392" cy="171200"/>
           </a:xfrm>
           <a:prstGeom prst="rect">
@@ -5660,27 +6061,27 @@
         </p:nvSpPr>
         <p:spPr>
           <a:xfrm>
-            <a:off x="1042416" y="2506221"/>
-            <a:ext cx="5422392" cy="323332"/>
-          </a:xfrm>
-          <a:prstGeom prst="rect">
-            <a:avLst/>
-          </a:prstGeom>
-          <a:noFill/>
-        </p:spPr>
-        <p:txBody>
-          <a:bodyPr wrap="square" lIns="0" rIns="0" tIns="0" bIns="0" anchor="t">
-            <a:noAutofit/>
-          </a:bodyPr>
-          <a:lstStyle/>
-          <a:p>
-            <a:pPr algn="l">
-              <a:lnSpc>
-                <a:spcPct val="130000"/>
-              </a:lnSpc>
-            </a:pPr>
-            <a:r>
-              <a:rPr sz="960" b="0" i="0">
+            <a:off x="1042416" y="2667759"/>
+            <a:ext cx="5422392" cy="338566"/>
+          </a:xfrm>
+          <a:prstGeom prst="rect">
+            <a:avLst/>
+          </a:prstGeom>
+          <a:noFill/>
+        </p:spPr>
+        <p:txBody>
+          <a:bodyPr wrap="square" lIns="0" rIns="0" tIns="0" bIns="0" anchor="t">
+            <a:noAutofit/>
+          </a:bodyPr>
+          <a:lstStyle/>
+          <a:p>
+            <a:pPr algn="l">
+              <a:lnSpc>
+                <a:spcPct val="132000"/>
+              </a:lnSpc>
+            </a:pPr>
+            <a:r>
+              <a:rPr sz="990" b="0" i="0">
                 <a:solidFill>
                   <a:srgbClr val="44546A"/>
                 </a:solidFill>
@@ -5699,7 +6100,7 @@
         </p:nvCxnSpPr>
         <p:spPr>
           <a:xfrm>
-            <a:off x="658368" y="2966713"/>
+            <a:off x="658368" y="3207493"/>
             <a:ext cx="5623560" cy="0"/>
           </a:xfrm>
           <a:prstGeom prst="line">
@@ -5734,7 +6135,7 @@
         </p:nvSpPr>
         <p:spPr>
           <a:xfrm>
-            <a:off x="658368" y="3140449"/>
+            <a:off x="658368" y="3463525"/>
             <a:ext cx="310896" cy="237744"/>
           </a:xfrm>
           <a:prstGeom prst="rect">
@@ -5773,7 +6174,7 @@
         </p:nvSpPr>
         <p:spPr>
           <a:xfrm>
-            <a:off x="1042416" y="3103873"/>
+            <a:off x="1042416" y="3426949"/>
             <a:ext cx="5422392" cy="171200"/>
           </a:xfrm>
           <a:prstGeom prst="rect">
@@ -5812,27 +6213,27 @@
         </p:nvSpPr>
         <p:spPr>
           <a:xfrm>
-            <a:off x="1042416" y="3311649"/>
-            <a:ext cx="5422392" cy="323332"/>
-          </a:xfrm>
-          <a:prstGeom prst="rect">
-            <a:avLst/>
-          </a:prstGeom>
-          <a:noFill/>
-        </p:spPr>
-        <p:txBody>
-          <a:bodyPr wrap="square" lIns="0" rIns="0" tIns="0" bIns="0" anchor="t">
-            <a:noAutofit/>
-          </a:bodyPr>
-          <a:lstStyle/>
-          <a:p>
-            <a:pPr algn="l">
-              <a:lnSpc>
-                <a:spcPct val="130000"/>
-              </a:lnSpc>
-            </a:pPr>
-            <a:r>
-              <a:rPr sz="960" b="0" i="0">
+            <a:off x="1042416" y="3634725"/>
+            <a:ext cx="5422392" cy="338566"/>
+          </a:xfrm>
+          <a:prstGeom prst="rect">
+            <a:avLst/>
+          </a:prstGeom>
+          <a:noFill/>
+        </p:spPr>
+        <p:txBody>
+          <a:bodyPr wrap="square" lIns="0" rIns="0" tIns="0" bIns="0" anchor="t">
+            <a:noAutofit/>
+          </a:bodyPr>
+          <a:lstStyle/>
+          <a:p>
+            <a:pPr algn="l">
+              <a:lnSpc>
+                <a:spcPct val="132000"/>
+              </a:lnSpc>
+            </a:pPr>
+            <a:r>
+              <a:rPr sz="990" b="0" i="0">
                 <a:solidFill>
                   <a:srgbClr val="44546A"/>
                 </a:solidFill>
@@ -5851,7 +6252,7 @@
         </p:nvCxnSpPr>
         <p:spPr>
           <a:xfrm>
-            <a:off x="658368" y="3772141"/>
+            <a:off x="658368" y="4174459"/>
             <a:ext cx="5623560" cy="0"/>
           </a:xfrm>
           <a:prstGeom prst="line">
@@ -5886,7 +6287,7 @@
         </p:nvSpPr>
         <p:spPr>
           <a:xfrm>
-            <a:off x="658368" y="3945877"/>
+            <a:off x="658368" y="4430491"/>
             <a:ext cx="310896" cy="237744"/>
           </a:xfrm>
           <a:prstGeom prst="rect">
@@ -5925,7 +6326,7 @@
         </p:nvSpPr>
         <p:spPr>
           <a:xfrm>
-            <a:off x="1042416" y="3909301"/>
+            <a:off x="1042416" y="4393915"/>
             <a:ext cx="5422392" cy="171200"/>
           </a:xfrm>
           <a:prstGeom prst="rect">
@@ -5964,27 +6365,27 @@
         </p:nvSpPr>
         <p:spPr>
           <a:xfrm>
-            <a:off x="1042416" y="4117077"/>
-            <a:ext cx="5422392" cy="323332"/>
-          </a:xfrm>
-          <a:prstGeom prst="rect">
-            <a:avLst/>
-          </a:prstGeom>
-          <a:noFill/>
-        </p:spPr>
-        <p:txBody>
-          <a:bodyPr wrap="square" lIns="0" rIns="0" tIns="0" bIns="0" anchor="t">
-            <a:noAutofit/>
-          </a:bodyPr>
-          <a:lstStyle/>
-          <a:p>
-            <a:pPr algn="l">
-              <a:lnSpc>
-                <a:spcPct val="130000"/>
-              </a:lnSpc>
-            </a:pPr>
-            <a:r>
-              <a:rPr sz="960" b="0" i="0">
+            <a:off x="1042416" y="4601691"/>
+            <a:ext cx="5422392" cy="338566"/>
+          </a:xfrm>
+          <a:prstGeom prst="rect">
+            <a:avLst/>
+          </a:prstGeom>
+          <a:noFill/>
+        </p:spPr>
+        <p:txBody>
+          <a:bodyPr wrap="square" lIns="0" rIns="0" tIns="0" bIns="0" anchor="t">
+            <a:noAutofit/>
+          </a:bodyPr>
+          <a:lstStyle/>
+          <a:p>
+            <a:pPr algn="l">
+              <a:lnSpc>
+                <a:spcPct val="132000"/>
+              </a:lnSpc>
+            </a:pPr>
+            <a:r>
+              <a:rPr sz="990" b="0" i="0">
                 <a:solidFill>
                   <a:srgbClr val="44546A"/>
                 </a:solidFill>
@@ -5997,125 +6398,14 @@
       </p:sp>
       <p:sp>
         <p:nvSpPr>
-          <p:cNvPr id="23" name="TextBox 22"/>
-          <p:cNvSpPr txBox="1"/>
-          <p:nvPr/>
-        </p:nvSpPr>
-        <p:spPr>
-          <a:xfrm>
-            <a:off x="658368" y="4787881"/>
-            <a:ext cx="5806440" cy="530352"/>
-          </a:xfrm>
-          <a:prstGeom prst="rect">
-            <a:avLst/>
-          </a:prstGeom>
-          <a:noFill/>
-        </p:spPr>
-        <p:txBody>
-          <a:bodyPr wrap="square" lIns="0" rIns="0" tIns="0" bIns="0" anchor="t">
-            <a:noAutofit/>
-          </a:bodyPr>
-          <a:lstStyle/>
-          <a:p>
-            <a:pPr algn="l">
-              <a:lnSpc>
-                <a:spcPct val="130000"/>
-              </a:lnSpc>
-            </a:pPr>
-            <a:r>
-              <a:rPr sz="919" b="1" i="0">
-                <a:solidFill>
-                  <a:srgbClr val="12263F"/>
-                </a:solidFill>
-                <a:latin typeface="Calibri"/>
-              </a:rPr>
-              <a:t>Definition check:  </a:t>
-            </a:r>
-            <a:r>
-              <a:rPr sz="919" b="0" i="0">
-                <a:solidFill>
-                  <a:srgbClr val="44546A"/>
-                </a:solidFill>
-                <a:latin typeface="Calibri"/>
-              </a:rPr>
-              <a:t>not perfect competition — only four price-makers, and entry is not free. Not a monopoly — no single firm can dictate price.</a:t>
-            </a:r>
-          </a:p>
-        </p:txBody>
-      </p:sp>
-      <p:pic>
-        <p:nvPicPr>
-          <p:cNvPr id="24" name="Picture 23" descr="chart_market_share.png"/>
-          <p:cNvPicPr>
-            <a:picLocks noChangeAspect="1"/>
-          </p:cNvPicPr>
-          <p:nvPr/>
-        </p:nvPicPr>
-        <p:blipFill>
-          <a:blip r:embed="rId2"/>
-          <a:stretch>
-            <a:fillRect/>
-          </a:stretch>
-        </p:blipFill>
-        <p:spPr>
-          <a:xfrm>
-            <a:off x="6915607" y="1547881"/>
-            <a:ext cx="4617720" cy="2637261"/>
-          </a:xfrm>
-          <a:prstGeom prst="rect">
-            <a:avLst/>
-          </a:prstGeom>
-        </p:spPr>
-      </p:pic>
-      <p:sp>
-        <p:nvSpPr>
-          <p:cNvPr id="25" name="TextBox 24"/>
-          <p:cNvSpPr txBox="1"/>
-          <p:nvPr/>
-        </p:nvSpPr>
-        <p:spPr>
-          <a:xfrm>
-            <a:off x="6915607" y="4258294"/>
-            <a:ext cx="4617720" cy="296388"/>
-          </a:xfrm>
-          <a:prstGeom prst="rect">
-            <a:avLst/>
-          </a:prstGeom>
-          <a:noFill/>
-        </p:spPr>
-        <p:txBody>
-          <a:bodyPr wrap="square" lIns="0" rIns="0" tIns="0" bIns="0" anchor="t">
-            <a:noAutofit/>
-          </a:bodyPr>
-          <a:lstStyle/>
-          <a:p>
-            <a:pPr algn="l">
-              <a:lnSpc>
-                <a:spcPct val="130000"/>
-              </a:lnSpc>
-            </a:pPr>
-            <a:r>
-              <a:rPr sz="880" b="0" i="0">
-                <a:solidFill>
-                  <a:srgbClr val="7B8B9E"/>
-                </a:solidFill>
-                <a:latin typeface="Calibri"/>
-              </a:rPr>
-              <a:t>Concentration is the first test of an oligopoly: four firms, not the market, decide the price. Rivals track each other's prices and volumes week by week.</a:t>
-            </a:r>
-          </a:p>
-        </p:txBody>
-      </p:sp>
-      <p:sp>
-        <p:nvSpPr>
-          <p:cNvPr id="26" name="Rounded Rectangle 25"/>
+          <p:cNvPr id="23" name="Rounded Rectangle 22"/>
           <p:cNvSpPr/>
           <p:nvPr/>
         </p:nvSpPr>
         <p:spPr>
           <a:xfrm>
-            <a:off x="6915607" y="4664410"/>
-            <a:ext cx="4617720" cy="566928"/>
+            <a:off x="658368" y="5047488"/>
+            <a:ext cx="5806440" cy="621792"/>
           </a:xfrm>
           <a:prstGeom prst="roundRect">
             <a:avLst>
@@ -6156,7 +6446,210 @@
       </p:sp>
       <p:sp>
         <p:nvSpPr>
+          <p:cNvPr id="24" name="Rectangle 23"/>
+          <p:cNvSpPr/>
+          <p:nvPr/>
+        </p:nvSpPr>
+        <p:spPr>
+          <a:xfrm>
+            <a:off x="658368" y="5047488"/>
+            <a:ext cx="41148" cy="621792"/>
+          </a:xfrm>
+          <a:prstGeom prst="rect">
+            <a:avLst/>
+          </a:prstGeom>
+          <a:solidFill>
+            <a:srgbClr val="12263F"/>
+          </a:solidFill>
+          <a:ln>
+            <a:noFill/>
+          </a:ln>
+          <a:effectLst/>
+        </p:spPr>
+        <p:style>
+          <a:lnRef idx="1">
+            <a:schemeClr val="accent1"/>
+          </a:lnRef>
+          <a:fillRef idx="3">
+            <a:schemeClr val="accent1"/>
+          </a:fillRef>
+          <a:effectRef idx="2">
+            <a:schemeClr val="accent1"/>
+          </a:effectRef>
+          <a:fontRef idx="minor">
+            <a:schemeClr val="lt1"/>
+          </a:fontRef>
+        </p:style>
+        <p:txBody>
+          <a:bodyPr rtlCol="0" anchor="ctr" wrap="square"/>
+          <a:lstStyle/>
+          <a:p>
+            <a:pPr algn="ctr"/>
+          </a:p>
+        </p:txBody>
+      </p:sp>
+      <p:sp>
+        <p:nvSpPr>
+          <p:cNvPr id="25" name="TextBox 24"/>
+          <p:cNvSpPr txBox="1"/>
+          <p:nvPr/>
+        </p:nvSpPr>
+        <p:spPr>
+          <a:xfrm>
+            <a:off x="859536" y="5047488"/>
+            <a:ext cx="5404104" cy="621792"/>
+          </a:xfrm>
+          <a:prstGeom prst="rect">
+            <a:avLst/>
+          </a:prstGeom>
+          <a:noFill/>
+        </p:spPr>
+        <p:txBody>
+          <a:bodyPr wrap="square" lIns="0" rIns="0" tIns="0" bIns="0" anchor="ctr">
+            <a:noAutofit/>
+          </a:bodyPr>
+          <a:lstStyle/>
+          <a:p>
+            <a:pPr algn="l">
+              <a:lnSpc>
+                <a:spcPct val="130000"/>
+              </a:lnSpc>
+            </a:pPr>
+            <a:r>
+              <a:rPr sz="919" b="1" i="0">
+                <a:solidFill>
+                  <a:srgbClr val="12263F"/>
+                </a:solidFill>
+                <a:latin typeface="Calibri"/>
+              </a:rPr>
+              <a:t>Definition check:  </a:t>
+            </a:r>
+            <a:r>
+              <a:rPr sz="919" b="0" i="0">
+                <a:solidFill>
+                  <a:srgbClr val="44546A"/>
+                </a:solidFill>
+                <a:latin typeface="Calibri"/>
+              </a:rPr>
+              <a:t>not perfect competition — only four price-makers, and entry is not free. Not a monopoly — no single firm can dictate price.</a:t>
+            </a:r>
+          </a:p>
+        </p:txBody>
+      </p:sp>
+      <p:pic>
+        <p:nvPicPr>
+          <p:cNvPr id="26" name="Picture 25" descr="chart_market_share.png"/>
+          <p:cNvPicPr>
+            <a:picLocks noChangeAspect="1"/>
+          </p:cNvPicPr>
+          <p:nvPr/>
+        </p:nvPicPr>
+        <p:blipFill>
+          <a:blip r:embed="rId3"/>
+          <a:stretch>
+            <a:fillRect/>
+          </a:stretch>
+        </p:blipFill>
+        <p:spPr>
+          <a:xfrm>
+            <a:off x="6915607" y="1547881"/>
+            <a:ext cx="4617720" cy="2637261"/>
+          </a:xfrm>
+          <a:prstGeom prst="rect">
+            <a:avLst/>
+          </a:prstGeom>
+        </p:spPr>
+      </p:pic>
+      <p:sp>
+        <p:nvSpPr>
           <p:cNvPr id="27" name="TextBox 26"/>
+          <p:cNvSpPr txBox="1"/>
+          <p:nvPr/>
+        </p:nvSpPr>
+        <p:spPr>
+          <a:xfrm>
+            <a:off x="6915607" y="4258294"/>
+            <a:ext cx="4617720" cy="296388"/>
+          </a:xfrm>
+          <a:prstGeom prst="rect">
+            <a:avLst/>
+          </a:prstGeom>
+          <a:noFill/>
+        </p:spPr>
+        <p:txBody>
+          <a:bodyPr wrap="square" lIns="0" rIns="0" tIns="0" bIns="0" anchor="t">
+            <a:noAutofit/>
+          </a:bodyPr>
+          <a:lstStyle/>
+          <a:p>
+            <a:pPr algn="l">
+              <a:lnSpc>
+                <a:spcPct val="130000"/>
+              </a:lnSpc>
+            </a:pPr>
+            <a:r>
+              <a:rPr sz="880" b="0" i="0">
+                <a:solidFill>
+                  <a:srgbClr val="7B8B9E"/>
+                </a:solidFill>
+                <a:latin typeface="Calibri"/>
+              </a:rPr>
+              <a:t>Concentration is the first test of an oligopoly: four firms, not the market, decide the price. Rivals track each other's prices and volumes week by week.</a:t>
+            </a:r>
+          </a:p>
+        </p:txBody>
+      </p:sp>
+      <p:sp>
+        <p:nvSpPr>
+          <p:cNvPr id="28" name="Rounded Rectangle 27"/>
+          <p:cNvSpPr/>
+          <p:nvPr/>
+        </p:nvSpPr>
+        <p:spPr>
+          <a:xfrm>
+            <a:off x="6915607" y="4664410"/>
+            <a:ext cx="4617720" cy="566928"/>
+          </a:xfrm>
+          <a:prstGeom prst="roundRect">
+            <a:avLst>
+              <a:gd name="adj" fmla="val 4000"/>
+            </a:avLst>
+          </a:prstGeom>
+          <a:solidFill>
+            <a:srgbClr val="F7F9FC"/>
+          </a:solidFill>
+          <a:ln w="7620">
+            <a:solidFill>
+              <a:srgbClr val="DCE3EC"/>
+            </a:solidFill>
+          </a:ln>
+          <a:effectLst/>
+        </p:spPr>
+        <p:style>
+          <a:lnRef idx="1">
+            <a:schemeClr val="accent1"/>
+          </a:lnRef>
+          <a:fillRef idx="3">
+            <a:schemeClr val="accent1"/>
+          </a:fillRef>
+          <a:effectRef idx="2">
+            <a:schemeClr val="accent1"/>
+          </a:effectRef>
+          <a:fontRef idx="minor">
+            <a:schemeClr val="lt1"/>
+          </a:fontRef>
+        </p:style>
+        <p:txBody>
+          <a:bodyPr rtlCol="0" anchor="ctr" wrap="square"/>
+          <a:lstStyle/>
+          <a:p>
+            <a:pPr algn="ctr"/>
+          </a:p>
+        </p:txBody>
+      </p:sp>
+      <p:sp>
+        <p:nvSpPr>
+          <p:cNvPr id="29" name="TextBox 28"/>
           <p:cNvSpPr txBox="1"/>
           <p:nvPr/>
         </p:nvSpPr>
@@ -6204,7 +6697,7 @@
       </p:sp>
       <p:sp>
         <p:nvSpPr>
-          <p:cNvPr id="28" name="Rounded Rectangle 27"/>
+          <p:cNvPr id="30" name="Rounded Rectangle 29"/>
           <p:cNvSpPr/>
           <p:nvPr/>
         </p:nvSpPr>
@@ -6250,7 +6743,7 @@
       </p:sp>
       <p:sp>
         <p:nvSpPr>
-          <p:cNvPr id="29" name="Rectangle 28"/>
+          <p:cNvPr id="31" name="Rectangle 30"/>
           <p:cNvSpPr/>
           <p:nvPr/>
         </p:nvSpPr>
@@ -6294,7 +6787,7 @@
       </p:sp>
       <p:sp>
         <p:nvSpPr>
-          <p:cNvPr id="30" name="TextBox 29"/>
+          <p:cNvPr id="32" name="TextBox 31"/>
           <p:cNvSpPr txBox="1"/>
           <p:nvPr/>
         </p:nvSpPr>
@@ -6342,7 +6835,7 @@
       </p:sp>
       <p:cxnSp>
         <p:nvCxnSpPr>
-          <p:cNvPr id="31" name="Connector 30"/>
+          <p:cNvPr id="33" name="Connector 32"/>
           <p:cNvCxnSpPr/>
           <p:nvPr/>
         </p:nvCxnSpPr>
@@ -6377,7 +6870,7 @@
       </p:cxnSp>
       <p:sp>
         <p:nvSpPr>
-          <p:cNvPr id="32" name="TextBox 31"/>
+          <p:cNvPr id="34" name="TextBox 33"/>
           <p:cNvSpPr txBox="1"/>
           <p:nvPr/>
         </p:nvSpPr>
@@ -6416,7 +6909,7 @@
       </p:sp>
       <p:sp>
         <p:nvSpPr>
-          <p:cNvPr id="33" name="TextBox 32"/>
+          <p:cNvPr id="35" name="TextBox 34"/>
           <p:cNvSpPr txBox="1"/>
           <p:nvPr/>
         </p:nvSpPr>
@@ -6455,7 +6948,7 @@
       </p:sp>
       <p:sp>
         <p:nvSpPr>
-          <p:cNvPr id="34" name="TextBox 33"/>
+          <p:cNvPr id="36" name="TextBox 35"/>
           <p:cNvSpPr txBox="1"/>
           <p:nvPr/>
         </p:nvSpPr>
@@ -6494,7 +6987,7 @@
       </p:sp>
       <p:sp>
         <p:nvSpPr>
-          <p:cNvPr id="35" name="TextBox 34"/>
+          <p:cNvPr id="37" name="TextBox 36"/>
           <p:cNvSpPr txBox="1"/>
           <p:nvPr/>
         </p:nvSpPr>
@@ -6602,7 +7095,7 @@
         <p:spPr>
           <a:xfrm>
             <a:off x="658368" y="310896"/>
-            <a:ext cx="6035040" cy="182880"/>
+            <a:ext cx="5669280" cy="182880"/>
           </a:xfrm>
           <a:prstGeom prst="rect">
             <a:avLst/>
@@ -6640,8 +7133,8 @@
         </p:nvSpPr>
         <p:spPr>
           <a:xfrm>
-            <a:off x="7327087" y="310896"/>
-            <a:ext cx="4206240" cy="182880"/>
+            <a:off x="6595567" y="310896"/>
+            <a:ext cx="4937760" cy="182880"/>
           </a:xfrm>
           <a:prstGeom prst="rect">
             <a:avLst/>
@@ -6662,9 +7155,10 @@
             <a:r>
               <a:rPr sz="760" b="1" i="0" spc="110">
                 <a:solidFill>
-                  <a:srgbClr val="7B8B9E"/>
-                </a:solidFill>
-                <a:latin typeface="Calibri"/>
+                  <a:srgbClr val="2B6CB0"/>
+                </a:solidFill>
+                <a:latin typeface="Calibri"/>
+                <a:hlinkClick r:id="rId2"/>
               </a:rPr>
               <a:t>LECTURE LINK · SESSION 5: PRICING STRATEGIES</a:t>
             </a:r>
@@ -6793,15 +7287,15 @@
           <p:nvPr/>
         </p:nvPicPr>
         <p:blipFill>
-          <a:blip r:embed="rId2"/>
+          <a:blip r:embed="rId3"/>
           <a:stretch>
             <a:fillRect/>
           </a:stretch>
         </p:blipFill>
         <p:spPr>
           <a:xfrm>
-            <a:off x="658368" y="1401577"/>
-            <a:ext cx="5413248" cy="3188071"/>
+            <a:off x="658368" y="1365001"/>
+            <a:ext cx="6053328" cy="3565039"/>
           </a:xfrm>
           <a:prstGeom prst="rect">
             <a:avLst/>
@@ -6816,8 +7310,8 @@
         </p:nvSpPr>
         <p:spPr>
           <a:xfrm>
-            <a:off x="658368" y="5102352"/>
-            <a:ext cx="10874959" cy="658368"/>
+            <a:off x="658368" y="5175504"/>
+            <a:ext cx="10874959" cy="731520"/>
           </a:xfrm>
           <a:prstGeom prst="roundRect">
             <a:avLst>
@@ -6864,8 +7358,8 @@
         </p:nvSpPr>
         <p:spPr>
           <a:xfrm>
-            <a:off x="841248" y="5102352"/>
-            <a:ext cx="1572768" cy="658368"/>
+            <a:off x="841248" y="5175504"/>
+            <a:ext cx="1572768" cy="731520"/>
           </a:xfrm>
           <a:prstGeom prst="rect">
             <a:avLst/>
@@ -6904,8 +7398,8 @@
         </p:nvCxnSpPr>
         <p:spPr>
           <a:xfrm>
-            <a:off x="2505456" y="5212080"/>
-            <a:ext cx="0" cy="438912"/>
+            <a:off x="2505456" y="5285232"/>
+            <a:ext cx="0" cy="512064"/>
           </a:xfrm>
           <a:prstGeom prst="line">
             <a:avLst/>
@@ -6939,8 +7433,8 @@
         </p:nvSpPr>
         <p:spPr>
           <a:xfrm>
-            <a:off x="2670048" y="5102352"/>
-            <a:ext cx="8680399" cy="658368"/>
+            <a:off x="2670048" y="5175504"/>
+            <a:ext cx="8680399" cy="731520"/>
           </a:xfrm>
           <a:prstGeom prst="rect">
             <a:avLst/>
@@ -6987,8 +7481,8 @@
         </p:nvSpPr>
         <p:spPr>
           <a:xfrm>
-            <a:off x="6815023" y="1401577"/>
-            <a:ext cx="4718304" cy="958748"/>
+            <a:off x="6906463" y="1401577"/>
+            <a:ext cx="4626864" cy="1061824"/>
           </a:xfrm>
           <a:prstGeom prst="roundRect">
             <a:avLst>
@@ -7033,8 +7527,8 @@
         </p:nvSpPr>
         <p:spPr>
           <a:xfrm>
-            <a:off x="6815023" y="1401577"/>
-            <a:ext cx="41148" cy="958748"/>
+            <a:off x="6906463" y="1401577"/>
+            <a:ext cx="41148" cy="1061824"/>
           </a:xfrm>
           <a:prstGeom prst="rect">
             <a:avLst/>
@@ -7077,8 +7571,8 @@
         </p:nvSpPr>
         <p:spPr>
           <a:xfrm>
-            <a:off x="7016191" y="1538737"/>
-            <a:ext cx="4315968" cy="164775"/>
+            <a:off x="7107631" y="1566169"/>
+            <a:ext cx="4224528" cy="164775"/>
           </a:xfrm>
           <a:prstGeom prst="rect">
             <a:avLst/>
@@ -7116,27 +7610,27 @@
         </p:nvSpPr>
         <p:spPr>
           <a:xfrm>
-            <a:off x="7016191" y="1749232"/>
-            <a:ext cx="4315968" cy="464790"/>
-          </a:xfrm>
-          <a:prstGeom prst="rect">
-            <a:avLst/>
-          </a:prstGeom>
-          <a:noFill/>
-        </p:spPr>
-        <p:txBody>
-          <a:bodyPr wrap="square" lIns="0" rIns="0" tIns="0" bIns="0" anchor="t">
-            <a:noAutofit/>
-          </a:bodyPr>
-          <a:lstStyle/>
-          <a:p>
-            <a:pPr algn="l">
-              <a:lnSpc>
-                <a:spcPct val="130000"/>
-              </a:lnSpc>
-            </a:pPr>
-            <a:r>
-              <a:rPr sz="919" b="0" i="0">
+            <a:off x="7107631" y="1785808"/>
+            <a:ext cx="4224528" cy="494713"/>
+          </a:xfrm>
+          <a:prstGeom prst="rect">
+            <a:avLst/>
+          </a:prstGeom>
+          <a:noFill/>
+        </p:spPr>
+        <p:txBody>
+          <a:bodyPr wrap="square" lIns="0" rIns="0" tIns="0" bIns="0" anchor="t">
+            <a:noAutofit/>
+          </a:bodyPr>
+          <a:lstStyle/>
+          <a:p>
+            <a:pPr algn="l">
+              <a:lnSpc>
+                <a:spcPct val="134000"/>
+              </a:lnSpc>
+            </a:pPr>
+            <a:r>
+              <a:rPr sz="950" b="0" i="0">
                 <a:solidFill>
                   <a:srgbClr val="44546A"/>
                 </a:solidFill>
@@ -7145,7 +7639,7 @@
               <a:t>A petrol scooter cannot run without petrol, so Zenith-V substitutes for the whole petrol bundle. The link is a cross-price elasticity, </a:t>
             </a:r>
             <a:r>
-              <a:rPr sz="919" b="1" i="0">
+              <a:rPr sz="950" b="1" i="0">
                 <a:solidFill>
                   <a:srgbClr val="12263F"/>
                 </a:solidFill>
@@ -7154,7 +7648,7 @@
               <a:t>Exy &gt; 0</a:t>
             </a:r>
             <a:r>
-              <a:rPr sz="919" b="0" i="0">
+              <a:rPr sz="950" b="0" i="0">
                 <a:solidFill>
                   <a:srgbClr val="44546A"/>
                 </a:solidFill>
@@ -7173,8 +7667,8 @@
         </p:nvSpPr>
         <p:spPr>
           <a:xfrm>
-            <a:off x="6815023" y="2506629"/>
-            <a:ext cx="4718304" cy="958748"/>
+            <a:off x="6906463" y="2646281"/>
+            <a:ext cx="4626864" cy="1061824"/>
           </a:xfrm>
           <a:prstGeom prst="roundRect">
             <a:avLst>
@@ -7219,8 +7713,8 @@
         </p:nvSpPr>
         <p:spPr>
           <a:xfrm>
-            <a:off x="6815023" y="2506629"/>
-            <a:ext cx="41148" cy="958748"/>
+            <a:off x="6906463" y="2646281"/>
+            <a:ext cx="41148" cy="1061824"/>
           </a:xfrm>
           <a:prstGeom prst="rect">
             <a:avLst/>
@@ -7263,8 +7757,8 @@
         </p:nvSpPr>
         <p:spPr>
           <a:xfrm>
-            <a:off x="7016191" y="2643789"/>
-            <a:ext cx="4315968" cy="164775"/>
+            <a:off x="7107631" y="2810873"/>
+            <a:ext cx="4224528" cy="164775"/>
           </a:xfrm>
           <a:prstGeom prst="rect">
             <a:avLst/>
@@ -7302,27 +7796,27 @@
         </p:nvSpPr>
         <p:spPr>
           <a:xfrm>
-            <a:off x="7016191" y="2854284"/>
-            <a:ext cx="4315968" cy="464790"/>
-          </a:xfrm>
-          <a:prstGeom prst="rect">
-            <a:avLst/>
-          </a:prstGeom>
-          <a:noFill/>
-        </p:spPr>
-        <p:txBody>
-          <a:bodyPr wrap="square" lIns="0" rIns="0" tIns="0" bIns="0" anchor="t">
-            <a:noAutofit/>
-          </a:bodyPr>
-          <a:lstStyle/>
-          <a:p>
-            <a:pPr algn="l">
-              <a:lnSpc>
-                <a:spcPct val="130000"/>
-              </a:lnSpc>
-            </a:pPr>
-            <a:r>
-              <a:rPr sz="919" b="0" i="0">
+            <a:off x="7107631" y="3030512"/>
+            <a:ext cx="4224528" cy="494713"/>
+          </a:xfrm>
+          <a:prstGeom prst="rect">
+            <a:avLst/>
+          </a:prstGeom>
+          <a:noFill/>
+        </p:spPr>
+        <p:txBody>
+          <a:bodyPr wrap="square" lIns="0" rIns="0" tIns="0" bIns="0" anchor="t">
+            <a:noAutofit/>
+          </a:bodyPr>
+          <a:lstStyle/>
+          <a:p>
+            <a:pPr algn="l">
+              <a:lnSpc>
+                <a:spcPct val="134000"/>
+              </a:lnSpc>
+            </a:pPr>
+            <a:r>
+              <a:rPr sz="950" b="0" i="0">
                 <a:solidFill>
                   <a:srgbClr val="44546A"/>
                 </a:solidFill>
@@ -7331,7 +7825,7 @@
               <a:t>60 km a day at 45 km/l = 40 litres a month, about </a:t>
             </a:r>
             <a:r>
-              <a:rPr sz="919" b="1" i="0">
+              <a:rPr sz="950" b="1" i="0">
                 <a:solidFill>
                   <a:srgbClr val="12263F"/>
                 </a:solidFill>
@@ -7340,7 +7834,7 @@
               <a:t>₹4,200</a:t>
             </a:r>
             <a:r>
-              <a:rPr sz="919" b="0" i="0">
+              <a:rPr sz="950" b="0" i="0">
                 <a:solidFill>
                   <a:srgbClr val="44546A"/>
                 </a:solidFill>
@@ -7349,7 +7843,7 @@
               <a:t> at ₹105 a litre. The same distance on electricity costs about </a:t>
             </a:r>
             <a:r>
-              <a:rPr sz="919" b="1" i="0">
+              <a:rPr sz="950" b="1" i="0">
                 <a:solidFill>
                   <a:srgbClr val="12263F"/>
                 </a:solidFill>
@@ -7358,7 +7852,7 @@
               <a:t>₹360</a:t>
             </a:r>
             <a:r>
-              <a:rPr sz="919" b="0" i="0">
+              <a:rPr sz="950" b="0" i="0">
                 <a:solidFill>
                   <a:srgbClr val="44546A"/>
                 </a:solidFill>
@@ -7367,7 +7861,7 @@
               <a:t>. That </a:t>
             </a:r>
             <a:r>
-              <a:rPr sz="919" b="1" i="0">
+              <a:rPr sz="950" b="1" i="0">
                 <a:solidFill>
                   <a:srgbClr val="44546A"/>
                 </a:solidFill>
@@ -7376,7 +7870,7 @@
               <a:t>₹3,840 a month, ₹46,000 a year</a:t>
             </a:r>
             <a:r>
-              <a:rPr sz="919" b="0" i="0">
+              <a:rPr sz="950" b="0" i="0">
                 <a:solidFill>
                   <a:srgbClr val="44546A"/>
                 </a:solidFill>
@@ -7395,8 +7889,8 @@
         </p:nvSpPr>
         <p:spPr>
           <a:xfrm>
-            <a:off x="6815023" y="3611682"/>
-            <a:ext cx="4718304" cy="958748"/>
+            <a:off x="6906463" y="3890985"/>
+            <a:ext cx="4626864" cy="1061824"/>
           </a:xfrm>
           <a:prstGeom prst="roundRect">
             <a:avLst>
@@ -7441,8 +7935,8 @@
         </p:nvSpPr>
         <p:spPr>
           <a:xfrm>
-            <a:off x="6815023" y="3611682"/>
-            <a:ext cx="41148" cy="958748"/>
+            <a:off x="6906463" y="3890985"/>
+            <a:ext cx="41148" cy="1061824"/>
           </a:xfrm>
           <a:prstGeom prst="rect">
             <a:avLst/>
@@ -7485,8 +7979,8 @@
         </p:nvSpPr>
         <p:spPr>
           <a:xfrm>
-            <a:off x="7016191" y="3748842"/>
-            <a:ext cx="4315968" cy="164775"/>
+            <a:off x="7107631" y="4055577"/>
+            <a:ext cx="4224528" cy="164775"/>
           </a:xfrm>
           <a:prstGeom prst="rect">
             <a:avLst/>
@@ -7524,27 +8018,27 @@
         </p:nvSpPr>
         <p:spPr>
           <a:xfrm>
-            <a:off x="7016191" y="3959337"/>
-            <a:ext cx="4315968" cy="464790"/>
-          </a:xfrm>
-          <a:prstGeom prst="rect">
-            <a:avLst/>
-          </a:prstGeom>
-          <a:noFill/>
-        </p:spPr>
-        <p:txBody>
-          <a:bodyPr wrap="square" lIns="0" rIns="0" tIns="0" bIns="0" anchor="t">
-            <a:noAutofit/>
-          </a:bodyPr>
-          <a:lstStyle/>
-          <a:p>
-            <a:pPr algn="l">
-              <a:lnSpc>
-                <a:spcPct val="130000"/>
-              </a:lnSpc>
-            </a:pPr>
-            <a:r>
-              <a:rPr sz="919" b="0" i="0">
+            <a:off x="7107631" y="4275216"/>
+            <a:ext cx="4224528" cy="494713"/>
+          </a:xfrm>
+          <a:prstGeom prst="rect">
+            <a:avLst/>
+          </a:prstGeom>
+          <a:noFill/>
+        </p:spPr>
+        <p:txBody>
+          <a:bodyPr wrap="square" lIns="0" rIns="0" tIns="0" bIns="0" anchor="t">
+            <a:noAutofit/>
+          </a:bodyPr>
+          <a:lstStyle/>
+          <a:p>
+            <a:pPr algn="l">
+              <a:lnSpc>
+                <a:spcPct val="134000"/>
+              </a:lnSpc>
+            </a:pPr>
+            <a:r>
+              <a:rPr sz="950" b="0" i="0">
                 <a:solidFill>
                   <a:srgbClr val="44546A"/>
                 </a:solidFill>
@@ -7817,7 +8311,7 @@
         <p:spPr>
           <a:xfrm>
             <a:off x="658368" y="310896"/>
-            <a:ext cx="6035040" cy="182880"/>
+            <a:ext cx="5669280" cy="182880"/>
           </a:xfrm>
           <a:prstGeom prst="rect">
             <a:avLst/>
@@ -7855,8 +8349,8 @@
         </p:nvSpPr>
         <p:spPr>
           <a:xfrm>
-            <a:off x="7327087" y="310896"/>
-            <a:ext cx="4206240" cy="182880"/>
+            <a:off x="6595567" y="310896"/>
+            <a:ext cx="4937760" cy="182880"/>
           </a:xfrm>
           <a:prstGeom prst="rect">
             <a:avLst/>
@@ -7877,9 +8371,10 @@
             <a:r>
               <a:rPr sz="760" b="1" i="0" spc="110">
                 <a:solidFill>
-                  <a:srgbClr val="7B8B9E"/>
-                </a:solidFill>
-                <a:latin typeface="Calibri"/>
+                  <a:srgbClr val="2B6CB0"/>
+                </a:solidFill>
+                <a:latin typeface="Calibri"/>
+                <a:hlinkClick r:id="rId2"/>
               </a:rPr>
               <a:t>LECTURE LINK · SESSION 5: PRICING STRATEGIES</a:t>
             </a:r>
@@ -8270,7 +8765,7 @@
         <p:spPr>
           <a:xfrm>
             <a:off x="658368" y="2407417"/>
-            <a:ext cx="5760720" cy="402336"/>
+            <a:ext cx="5760720" cy="429768"/>
           </a:xfrm>
           <a:prstGeom prst="rect">
             <a:avLst/>
@@ -8316,7 +8811,7 @@
         <p:spPr>
           <a:xfrm>
             <a:off x="2505456" y="2407417"/>
-            <a:ext cx="1956816" cy="402336"/>
+            <a:ext cx="1956816" cy="429768"/>
           </a:xfrm>
           <a:prstGeom prst="rect">
             <a:avLst/>
@@ -8362,7 +8857,7 @@
         <p:spPr>
           <a:xfrm>
             <a:off x="768096" y="2407417"/>
-            <a:ext cx="1700784" cy="402336"/>
+            <a:ext cx="1700784" cy="429768"/>
           </a:xfrm>
           <a:prstGeom prst="rect">
             <a:avLst/>
@@ -8401,7 +8896,7 @@
         <p:spPr>
           <a:xfrm>
             <a:off x="2596896" y="2407417"/>
-            <a:ext cx="1792224" cy="402336"/>
+            <a:ext cx="1792224" cy="429768"/>
           </a:xfrm>
           <a:prstGeom prst="rect">
             <a:avLst/>
@@ -8440,7 +8935,7 @@
         <p:spPr>
           <a:xfrm>
             <a:off x="4553712" y="2407417"/>
-            <a:ext cx="1792224" cy="402336"/>
+            <a:ext cx="1792224" cy="429768"/>
           </a:xfrm>
           <a:prstGeom prst="rect">
             <a:avLst/>
@@ -8478,8 +8973,8 @@
         </p:nvSpPr>
         <p:spPr>
           <a:xfrm>
-            <a:off x="658368" y="2809753"/>
-            <a:ext cx="5760720" cy="402336"/>
+            <a:off x="658368" y="2837185"/>
+            <a:ext cx="5760720" cy="429768"/>
           </a:xfrm>
           <a:prstGeom prst="rect">
             <a:avLst/>
@@ -8524,8 +9019,8 @@
         </p:nvSpPr>
         <p:spPr>
           <a:xfrm>
-            <a:off x="2505456" y="2809753"/>
-            <a:ext cx="1956816" cy="402336"/>
+            <a:off x="2505456" y="2837185"/>
+            <a:ext cx="1956816" cy="429768"/>
           </a:xfrm>
           <a:prstGeom prst="rect">
             <a:avLst/>
@@ -8570,8 +9065,8 @@
         </p:nvSpPr>
         <p:spPr>
           <a:xfrm>
-            <a:off x="768096" y="2809753"/>
-            <a:ext cx="1700784" cy="402336"/>
+            <a:off x="768096" y="2837185"/>
+            <a:ext cx="1700784" cy="429768"/>
           </a:xfrm>
           <a:prstGeom prst="rect">
             <a:avLst/>
@@ -8609,8 +9104,8 @@
         </p:nvSpPr>
         <p:spPr>
           <a:xfrm>
-            <a:off x="2596896" y="2809753"/>
-            <a:ext cx="1792224" cy="402336"/>
+            <a:off x="2596896" y="2837185"/>
+            <a:ext cx="1792224" cy="429768"/>
           </a:xfrm>
           <a:prstGeom prst="rect">
             <a:avLst/>
@@ -8648,8 +9143,8 @@
         </p:nvSpPr>
         <p:spPr>
           <a:xfrm>
-            <a:off x="4553712" y="2809753"/>
-            <a:ext cx="1792224" cy="402336"/>
+            <a:off x="4553712" y="2837185"/>
+            <a:ext cx="1792224" cy="429768"/>
           </a:xfrm>
           <a:prstGeom prst="rect">
             <a:avLst/>
@@ -8687,8 +9182,8 @@
         </p:nvSpPr>
         <p:spPr>
           <a:xfrm>
-            <a:off x="658368" y="3212089"/>
-            <a:ext cx="5760720" cy="402336"/>
+            <a:off x="658368" y="3266953"/>
+            <a:ext cx="5760720" cy="429768"/>
           </a:xfrm>
           <a:prstGeom prst="rect">
             <a:avLst/>
@@ -8733,8 +9228,8 @@
         </p:nvSpPr>
         <p:spPr>
           <a:xfrm>
-            <a:off x="2505456" y="3212089"/>
-            <a:ext cx="1956816" cy="402336"/>
+            <a:off x="2505456" y="3266953"/>
+            <a:ext cx="1956816" cy="429768"/>
           </a:xfrm>
           <a:prstGeom prst="rect">
             <a:avLst/>
@@ -8779,8 +9274,8 @@
         </p:nvSpPr>
         <p:spPr>
           <a:xfrm>
-            <a:off x="768096" y="3212089"/>
-            <a:ext cx="1700784" cy="402336"/>
+            <a:off x="768096" y="3266953"/>
+            <a:ext cx="1700784" cy="429768"/>
           </a:xfrm>
           <a:prstGeom prst="rect">
             <a:avLst/>
@@ -8818,8 +9313,8 @@
         </p:nvSpPr>
         <p:spPr>
           <a:xfrm>
-            <a:off x="2596896" y="3212089"/>
-            <a:ext cx="1792224" cy="402336"/>
+            <a:off x="2596896" y="3266953"/>
+            <a:ext cx="1792224" cy="429768"/>
           </a:xfrm>
           <a:prstGeom prst="rect">
             <a:avLst/>
@@ -8857,8 +9352,8 @@
         </p:nvSpPr>
         <p:spPr>
           <a:xfrm>
-            <a:off x="4553712" y="3212089"/>
-            <a:ext cx="1792224" cy="402336"/>
+            <a:off x="4553712" y="3266953"/>
+            <a:ext cx="1792224" cy="429768"/>
           </a:xfrm>
           <a:prstGeom prst="rect">
             <a:avLst/>
@@ -8896,8 +9391,8 @@
         </p:nvSpPr>
         <p:spPr>
           <a:xfrm>
-            <a:off x="658368" y="3614425"/>
-            <a:ext cx="5760720" cy="402336"/>
+            <a:off x="658368" y="3696721"/>
+            <a:ext cx="5760720" cy="429768"/>
           </a:xfrm>
           <a:prstGeom prst="rect">
             <a:avLst/>
@@ -8942,8 +9437,8 @@
         </p:nvSpPr>
         <p:spPr>
           <a:xfrm>
-            <a:off x="2505456" y="3614425"/>
-            <a:ext cx="1956816" cy="402336"/>
+            <a:off x="2505456" y="3696721"/>
+            <a:ext cx="1956816" cy="429768"/>
           </a:xfrm>
           <a:prstGeom prst="rect">
             <a:avLst/>
@@ -8988,8 +9483,8 @@
         </p:nvSpPr>
         <p:spPr>
           <a:xfrm>
-            <a:off x="768096" y="3614425"/>
-            <a:ext cx="1700784" cy="402336"/>
+            <a:off x="768096" y="3696721"/>
+            <a:ext cx="1700784" cy="429768"/>
           </a:xfrm>
           <a:prstGeom prst="rect">
             <a:avLst/>
@@ -9027,8 +9522,8 @@
         </p:nvSpPr>
         <p:spPr>
           <a:xfrm>
-            <a:off x="2596896" y="3614425"/>
-            <a:ext cx="1792224" cy="402336"/>
+            <a:off x="2596896" y="3696721"/>
+            <a:ext cx="1792224" cy="429768"/>
           </a:xfrm>
           <a:prstGeom prst="rect">
             <a:avLst/>
@@ -9066,8 +9561,8 @@
         </p:nvSpPr>
         <p:spPr>
           <a:xfrm>
-            <a:off x="4553712" y="3614425"/>
-            <a:ext cx="1792224" cy="402336"/>
+            <a:off x="4553712" y="3696721"/>
+            <a:ext cx="1792224" cy="429768"/>
           </a:xfrm>
           <a:prstGeom prst="rect">
             <a:avLst/>
@@ -9105,8 +9600,8 @@
         </p:nvSpPr>
         <p:spPr>
           <a:xfrm>
-            <a:off x="658368" y="4016761"/>
-            <a:ext cx="5760720" cy="402336"/>
+            <a:off x="658368" y="4126489"/>
+            <a:ext cx="5760720" cy="429768"/>
           </a:xfrm>
           <a:prstGeom prst="rect">
             <a:avLst/>
@@ -9151,8 +9646,8 @@
         </p:nvSpPr>
         <p:spPr>
           <a:xfrm>
-            <a:off x="2505456" y="4016761"/>
-            <a:ext cx="1956816" cy="402336"/>
+            <a:off x="2505456" y="4126489"/>
+            <a:ext cx="1956816" cy="429768"/>
           </a:xfrm>
           <a:prstGeom prst="rect">
             <a:avLst/>
@@ -9197,8 +9692,8 @@
         </p:nvSpPr>
         <p:spPr>
           <a:xfrm>
-            <a:off x="768096" y="4016761"/>
-            <a:ext cx="1700784" cy="402336"/>
+            <a:off x="768096" y="4126489"/>
+            <a:ext cx="1700784" cy="429768"/>
           </a:xfrm>
           <a:prstGeom prst="rect">
             <a:avLst/>
@@ -9236,8 +9731,8 @@
         </p:nvSpPr>
         <p:spPr>
           <a:xfrm>
-            <a:off x="2596896" y="4016761"/>
-            <a:ext cx="1792224" cy="402336"/>
+            <a:off x="2596896" y="4126489"/>
+            <a:ext cx="1792224" cy="429768"/>
           </a:xfrm>
           <a:prstGeom prst="rect">
             <a:avLst/>
@@ -9275,8 +9770,8 @@
         </p:nvSpPr>
         <p:spPr>
           <a:xfrm>
-            <a:off x="4553712" y="4016761"/>
-            <a:ext cx="1792224" cy="402336"/>
+            <a:off x="4553712" y="4126489"/>
+            <a:ext cx="1792224" cy="429768"/>
           </a:xfrm>
           <a:prstGeom prst="rect">
             <a:avLst/>
@@ -9314,7 +9809,7 @@
         </p:nvSpPr>
         <p:spPr>
           <a:xfrm>
-            <a:off x="658368" y="4601977"/>
+            <a:off x="658368" y="4739137"/>
             <a:ext cx="5760720" cy="182880"/>
           </a:xfrm>
           <a:prstGeom prst="rect">
@@ -9353,7 +9848,7 @@
         </p:nvSpPr>
         <p:spPr>
           <a:xfrm>
-            <a:off x="658368" y="4821433"/>
+            <a:off x="658368" y="4967737"/>
             <a:ext cx="155448" cy="182880"/>
           </a:xfrm>
           <a:prstGeom prst="rect">
@@ -9373,7 +9868,7 @@
               </a:lnSpc>
             </a:pPr>
             <a:r>
-              <a:rPr sz="820" b="1" i="0">
+              <a:rPr sz="830" b="1" i="0">
                 <a:solidFill>
                   <a:srgbClr val="2B6CB0"/>
                 </a:solidFill>
@@ -9392,8 +9887,8 @@
         </p:nvSpPr>
         <p:spPr>
           <a:xfrm>
-            <a:off x="859536" y="4812289"/>
-            <a:ext cx="5559552" cy="143634"/>
+            <a:off x="859536" y="4958593"/>
+            <a:ext cx="5559552" cy="145266"/>
           </a:xfrm>
           <a:prstGeom prst="rect">
             <a:avLst/>
@@ -9412,7 +9907,7 @@
               </a:lnSpc>
             </a:pPr>
             <a:r>
-              <a:rPr sz="880" b="0" i="0">
+              <a:rPr sz="890" b="0" i="0">
                 <a:solidFill>
                   <a:srgbClr val="44546A"/>
                 </a:solidFill>
@@ -9431,7 +9926,7 @@
         </p:nvSpPr>
         <p:spPr>
           <a:xfrm>
-            <a:off x="658368" y="5015359"/>
+            <a:off x="658368" y="5190727"/>
             <a:ext cx="155448" cy="182880"/>
           </a:xfrm>
           <a:prstGeom prst="rect">
@@ -9451,7 +9946,7 @@
               </a:lnSpc>
             </a:pPr>
             <a:r>
-              <a:rPr sz="820" b="1" i="0">
+              <a:rPr sz="830" b="1" i="0">
                 <a:solidFill>
                   <a:srgbClr val="2B6CB0"/>
                 </a:solidFill>
@@ -9470,8 +9965,8 @@
         </p:nvSpPr>
         <p:spPr>
           <a:xfrm>
-            <a:off x="859536" y="5006215"/>
-            <a:ext cx="5559552" cy="143634"/>
+            <a:off x="859536" y="5181583"/>
+            <a:ext cx="5559552" cy="145266"/>
           </a:xfrm>
           <a:prstGeom prst="rect">
             <a:avLst/>
@@ -9490,7 +9985,7 @@
               </a:lnSpc>
             </a:pPr>
             <a:r>
-              <a:rPr sz="880" b="0" i="0">
+              <a:rPr sz="890" b="0" i="0">
                 <a:solidFill>
                   <a:srgbClr val="44546A"/>
                 </a:solidFill>
@@ -9509,7 +10004,7 @@
         </p:nvSpPr>
         <p:spPr>
           <a:xfrm>
-            <a:off x="658368" y="5209285"/>
+            <a:off x="658368" y="5413717"/>
             <a:ext cx="155448" cy="182880"/>
           </a:xfrm>
           <a:prstGeom prst="rect">
@@ -9529,7 +10024,7 @@
               </a:lnSpc>
             </a:pPr>
             <a:r>
-              <a:rPr sz="820" b="1" i="0">
+              <a:rPr sz="830" b="1" i="0">
                 <a:solidFill>
                   <a:srgbClr val="2B6CB0"/>
                 </a:solidFill>
@@ -9548,8 +10043,8 @@
         </p:nvSpPr>
         <p:spPr>
           <a:xfrm>
-            <a:off x="859536" y="5200141"/>
-            <a:ext cx="5559552" cy="143634"/>
+            <a:off x="859536" y="5404573"/>
+            <a:ext cx="5559552" cy="145266"/>
           </a:xfrm>
           <a:prstGeom prst="rect">
             <a:avLst/>
@@ -9568,7 +10063,7 @@
               </a:lnSpc>
             </a:pPr>
             <a:r>
-              <a:rPr sz="880" b="0" i="0">
+              <a:rPr sz="890" b="0" i="0">
                 <a:solidFill>
                   <a:srgbClr val="44546A"/>
                 </a:solidFill>
@@ -9588,7 +10083,7 @@
           <p:nvPr/>
         </p:nvPicPr>
         <p:blipFill>
-          <a:blip r:embed="rId2"/>
+          <a:blip r:embed="rId3"/>
           <a:stretch>
             <a:fillRect/>
           </a:stretch>
@@ -9650,7 +10145,7 @@
         </p:nvSpPr>
         <p:spPr>
           <a:xfrm>
-            <a:off x="658368" y="5614416"/>
+            <a:off x="658368" y="5632704"/>
             <a:ext cx="2636444" cy="566928"/>
           </a:xfrm>
           <a:prstGeom prst="roundRect">
@@ -9698,7 +10193,7 @@
         </p:nvSpPr>
         <p:spPr>
           <a:xfrm>
-            <a:off x="804672" y="5705856"/>
+            <a:off x="804672" y="5724144"/>
             <a:ext cx="2343836" cy="237744"/>
           </a:xfrm>
           <a:prstGeom prst="rect">
@@ -9737,7 +10232,7 @@
         </p:nvSpPr>
         <p:spPr>
           <a:xfrm>
-            <a:off x="804672" y="5943600"/>
+            <a:off x="804672" y="5961888"/>
             <a:ext cx="2343836" cy="182880"/>
           </a:xfrm>
           <a:prstGeom prst="rect">
@@ -9776,7 +10271,7 @@
         </p:nvSpPr>
         <p:spPr>
           <a:xfrm>
-            <a:off x="3404540" y="5614416"/>
+            <a:off x="3404540" y="5632704"/>
             <a:ext cx="2636444" cy="566928"/>
           </a:xfrm>
           <a:prstGeom prst="roundRect">
@@ -9824,7 +10319,7 @@
         </p:nvSpPr>
         <p:spPr>
           <a:xfrm>
-            <a:off x="3550844" y="5705856"/>
+            <a:off x="3550844" y="5724144"/>
             <a:ext cx="2343836" cy="237744"/>
           </a:xfrm>
           <a:prstGeom prst="rect">
@@ -9863,7 +10358,7 @@
         </p:nvSpPr>
         <p:spPr>
           <a:xfrm>
-            <a:off x="3550844" y="5943600"/>
+            <a:off x="3550844" y="5961888"/>
             <a:ext cx="2343836" cy="182880"/>
           </a:xfrm>
           <a:prstGeom prst="rect">
@@ -9902,7 +10397,7 @@
         </p:nvSpPr>
         <p:spPr>
           <a:xfrm>
-            <a:off x="6150712" y="5614416"/>
+            <a:off x="6150712" y="5632704"/>
             <a:ext cx="2636444" cy="566928"/>
           </a:xfrm>
           <a:prstGeom prst="roundRect">
@@ -9950,7 +10445,7 @@
         </p:nvSpPr>
         <p:spPr>
           <a:xfrm>
-            <a:off x="6297016" y="5705856"/>
+            <a:off x="6297016" y="5724144"/>
             <a:ext cx="2343836" cy="237744"/>
           </a:xfrm>
           <a:prstGeom prst="rect">
@@ -9989,7 +10484,7 @@
         </p:nvSpPr>
         <p:spPr>
           <a:xfrm>
-            <a:off x="6297016" y="5943600"/>
+            <a:off x="6297016" y="5961888"/>
             <a:ext cx="2343836" cy="182880"/>
           </a:xfrm>
           <a:prstGeom prst="rect">
@@ -10028,7 +10523,7 @@
         </p:nvSpPr>
         <p:spPr>
           <a:xfrm>
-            <a:off x="8896883" y="5614416"/>
+            <a:off x="8896883" y="5632704"/>
             <a:ext cx="2636444" cy="566928"/>
           </a:xfrm>
           <a:prstGeom prst="roundRect">
@@ -10076,7 +10571,7 @@
         </p:nvSpPr>
         <p:spPr>
           <a:xfrm>
-            <a:off x="9043187" y="5705856"/>
+            <a:off x="9043187" y="5724144"/>
             <a:ext cx="2343836" cy="237744"/>
           </a:xfrm>
           <a:prstGeom prst="rect">
@@ -10115,7 +10610,7 @@
         </p:nvSpPr>
         <p:spPr>
           <a:xfrm>
-            <a:off x="9043187" y="5943600"/>
+            <a:off x="9043187" y="5961888"/>
             <a:ext cx="2343836" cy="182880"/>
           </a:xfrm>
           <a:prstGeom prst="rect">
@@ -10408,7 +10903,7 @@
         <p:spPr>
           <a:xfrm>
             <a:off x="658368" y="310896"/>
-            <a:ext cx="6035040" cy="182880"/>
+            <a:ext cx="5669280" cy="182880"/>
           </a:xfrm>
           <a:prstGeom prst="rect">
             <a:avLst/>
@@ -10446,8 +10941,8 @@
         </p:nvSpPr>
         <p:spPr>
           <a:xfrm>
-            <a:off x="7327087" y="310896"/>
-            <a:ext cx="4206240" cy="182880"/>
+            <a:off x="6595567" y="310896"/>
+            <a:ext cx="4937760" cy="182880"/>
           </a:xfrm>
           <a:prstGeom prst="rect">
             <a:avLst/>
@@ -10468,9 +10963,10 @@
             <a:r>
               <a:rPr sz="760" b="1" i="0" spc="110">
                 <a:solidFill>
-                  <a:srgbClr val="7B8B9E"/>
-                </a:solidFill>
-                <a:latin typeface="Calibri"/>
+                  <a:srgbClr val="2B6CB0"/>
+                </a:solidFill>
+                <a:latin typeface="Calibri"/>
+                <a:hlinkClick r:id="rId2"/>
               </a:rPr>
               <a:t>LECTURE LINK · SESSION 7: GAME THEORY</a:t>
             </a:r>
@@ -10808,7 +11304,7 @@
         <p:spPr>
           <a:xfrm>
             <a:off x="658368" y="2114809"/>
-            <a:ext cx="1335024" cy="1060704"/>
+            <a:ext cx="1335024" cy="1207008"/>
           </a:xfrm>
           <a:prstGeom prst="rect">
             <a:avLst/>
@@ -10866,7 +11362,7 @@
         <p:spPr>
           <a:xfrm>
             <a:off x="2157984" y="2114809"/>
-            <a:ext cx="1755648" cy="1060704"/>
+            <a:ext cx="1755648" cy="1207008"/>
           </a:xfrm>
           <a:prstGeom prst="rect">
             <a:avLst/>
@@ -10911,7 +11407,7 @@
         </p:nvSpPr>
         <p:spPr>
           <a:xfrm>
-            <a:off x="2157984" y="2297689"/>
+            <a:off x="2157984" y="2352553"/>
             <a:ext cx="1755648" cy="292608"/>
           </a:xfrm>
           <a:prstGeom prst="rect">
@@ -10950,7 +11446,7 @@
         </p:nvSpPr>
         <p:spPr>
           <a:xfrm>
-            <a:off x="2157984" y="2681737"/>
+            <a:off x="2157984" y="2754889"/>
             <a:ext cx="1755648" cy="237744"/>
           </a:xfrm>
           <a:prstGeom prst="rect">
@@ -10989,7 +11485,7 @@
         </p:nvSpPr>
         <p:spPr>
           <a:xfrm>
-            <a:off x="2534920" y="2937769"/>
+            <a:off x="2534920" y="3056641"/>
             <a:ext cx="1001776" cy="173736"/>
           </a:xfrm>
           <a:prstGeom prst="roundRect">
@@ -11051,7 +11547,7 @@
         <p:spPr>
           <a:xfrm>
             <a:off x="3986784" y="2114809"/>
-            <a:ext cx="1755648" cy="1060704"/>
+            <a:ext cx="1755648" cy="1207008"/>
           </a:xfrm>
           <a:prstGeom prst="rect">
             <a:avLst/>
@@ -11096,7 +11592,7 @@
         </p:nvSpPr>
         <p:spPr>
           <a:xfrm>
-            <a:off x="3986784" y="2297689"/>
+            <a:off x="3986784" y="2352553"/>
             <a:ext cx="1755648" cy="292608"/>
           </a:xfrm>
           <a:prstGeom prst="rect">
@@ -11135,7 +11631,7 @@
         </p:nvSpPr>
         <p:spPr>
           <a:xfrm>
-            <a:off x="3986784" y="2681737"/>
+            <a:off x="3986784" y="2754889"/>
             <a:ext cx="1755648" cy="237744"/>
           </a:xfrm>
           <a:prstGeom prst="rect">
@@ -11174,8 +11670,8 @@
         </p:nvSpPr>
         <p:spPr>
           <a:xfrm>
-            <a:off x="658368" y="3248665"/>
-            <a:ext cx="1335024" cy="1060704"/>
+            <a:off x="658368" y="3394969"/>
+            <a:ext cx="1335024" cy="1207008"/>
           </a:xfrm>
           <a:prstGeom prst="rect">
             <a:avLst/>
@@ -11232,8 +11728,8 @@
         </p:nvSpPr>
         <p:spPr>
           <a:xfrm>
-            <a:off x="2157984" y="3248665"/>
-            <a:ext cx="1755648" cy="1060704"/>
+            <a:off x="2157984" y="3394969"/>
+            <a:ext cx="1755648" cy="1207008"/>
           </a:xfrm>
           <a:prstGeom prst="rect">
             <a:avLst/>
@@ -11278,7 +11774,7 @@
         </p:nvSpPr>
         <p:spPr>
           <a:xfrm>
-            <a:off x="2157984" y="3431545"/>
+            <a:off x="2157984" y="3632713"/>
             <a:ext cx="1755648" cy="292608"/>
           </a:xfrm>
           <a:prstGeom prst="rect">
@@ -11317,7 +11813,7 @@
         </p:nvSpPr>
         <p:spPr>
           <a:xfrm>
-            <a:off x="2157984" y="3815593"/>
+            <a:off x="2157984" y="4035049"/>
             <a:ext cx="1755648" cy="237744"/>
           </a:xfrm>
           <a:prstGeom prst="rect">
@@ -11356,8 +11852,8 @@
         </p:nvSpPr>
         <p:spPr>
           <a:xfrm>
-            <a:off x="3986784" y="3248665"/>
-            <a:ext cx="1755648" cy="1060704"/>
+            <a:off x="3986784" y="3394969"/>
+            <a:ext cx="1755648" cy="1207008"/>
           </a:xfrm>
           <a:prstGeom prst="rect">
             <a:avLst/>
@@ -11402,7 +11898,7 @@
         </p:nvSpPr>
         <p:spPr>
           <a:xfrm>
-            <a:off x="3986784" y="3431545"/>
+            <a:off x="3986784" y="3632713"/>
             <a:ext cx="1755648" cy="292608"/>
           </a:xfrm>
           <a:prstGeom prst="rect">
@@ -11441,7 +11937,7 @@
         </p:nvSpPr>
         <p:spPr>
           <a:xfrm>
-            <a:off x="3986784" y="3815593"/>
+            <a:off x="3986784" y="4035049"/>
             <a:ext cx="1755648" cy="237744"/>
           </a:xfrm>
           <a:prstGeom prst="rect">
@@ -11480,7 +11976,7 @@
         </p:nvSpPr>
         <p:spPr>
           <a:xfrm>
-            <a:off x="658368" y="4437385"/>
+            <a:off x="658368" y="4729993"/>
             <a:ext cx="5084064" cy="658368"/>
           </a:xfrm>
           <a:prstGeom prst="rect">
@@ -12222,8 +12718,8 @@
         </p:nvSpPr>
         <p:spPr>
           <a:xfrm>
-            <a:off x="6729984" y="4498848"/>
-            <a:ext cx="4803343" cy="1280160"/>
+            <a:off x="6729984" y="4486153"/>
+            <a:ext cx="4803343" cy="1274567"/>
           </a:xfrm>
           <a:prstGeom prst="roundRect">
             <a:avLst>
@@ -12270,7 +12766,7 @@
         </p:nvSpPr>
         <p:spPr>
           <a:xfrm>
-            <a:off x="6912864" y="4599432"/>
+            <a:off x="6912864" y="4586737"/>
             <a:ext cx="4437583" cy="182880"/>
           </a:xfrm>
           <a:prstGeom prst="rect">
@@ -12309,7 +12805,7 @@
         </p:nvSpPr>
         <p:spPr>
           <a:xfrm>
-            <a:off x="6912864" y="4809744"/>
+            <a:off x="6912864" y="4797049"/>
             <a:ext cx="4437583" cy="165811"/>
           </a:xfrm>
           <a:prstGeom prst="rect">
@@ -12357,7 +12853,7 @@
         </p:nvSpPr>
         <p:spPr>
           <a:xfrm>
-            <a:off x="6912864" y="5053279"/>
+            <a:off x="6912864" y="5040584"/>
             <a:ext cx="4437583" cy="165811"/>
           </a:xfrm>
           <a:prstGeom prst="rect">
@@ -12405,7 +12901,7 @@
         </p:nvSpPr>
         <p:spPr>
           <a:xfrm>
-            <a:off x="6912864" y="5296814"/>
+            <a:off x="6912864" y="5284119"/>
             <a:ext cx="4437583" cy="165811"/>
           </a:xfrm>
           <a:prstGeom prst="rect">
@@ -12845,7 +13341,7 @@
         <p:spPr>
           <a:xfrm>
             <a:off x="658368" y="310896"/>
-            <a:ext cx="6035040" cy="182880"/>
+            <a:ext cx="5669280" cy="182880"/>
           </a:xfrm>
           <a:prstGeom prst="rect">
             <a:avLst/>
@@ -12883,8 +13379,8 @@
         </p:nvSpPr>
         <p:spPr>
           <a:xfrm>
-            <a:off x="7327087" y="310896"/>
-            <a:ext cx="4206240" cy="182880"/>
+            <a:off x="6595567" y="310896"/>
+            <a:ext cx="4937760" cy="182880"/>
           </a:xfrm>
           <a:prstGeom prst="rect">
             <a:avLst/>
@@ -12905,9 +13401,10 @@
             <a:r>
               <a:rPr sz="760" b="1" i="0" spc="110">
                 <a:solidFill>
-                  <a:srgbClr val="7B8B9E"/>
-                </a:solidFill>
-                <a:latin typeface="Calibri"/>
+                  <a:srgbClr val="2B6CB0"/>
+                </a:solidFill>
+                <a:latin typeface="Calibri"/>
+                <a:hlinkClick r:id="rId2"/>
               </a:rPr>
               <a:t>LECTURE LINK · SESSIONS 8 &amp; 9: RISK · CAPITAL BUDGETING</a:t>
             </a:r>
@@ -13924,7 +14421,7 @@
           <p:nvPr/>
         </p:nvPicPr>
         <p:blipFill>
-          <a:blip r:embed="rId2"/>
+          <a:blip r:embed="rId3"/>
           <a:stretch>
             <a:fillRect/>
           </a:stretch>
@@ -14025,8 +14522,8 @@
         </p:nvSpPr>
         <p:spPr>
           <a:xfrm>
-            <a:off x="658368" y="4681728"/>
-            <a:ext cx="5318608" cy="987552"/>
+            <a:off x="658368" y="4663440"/>
+            <a:ext cx="5318608" cy="950976"/>
           </a:xfrm>
           <a:prstGeom prst="roundRect">
             <a:avLst>
@@ -14071,8 +14568,8 @@
         </p:nvSpPr>
         <p:spPr>
           <a:xfrm>
-            <a:off x="658368" y="4681728"/>
-            <a:ext cx="41148" cy="987552"/>
+            <a:off x="658368" y="4663440"/>
+            <a:ext cx="41148" cy="950976"/>
           </a:xfrm>
           <a:prstGeom prst="rect">
             <a:avLst/>
@@ -14115,7 +14612,7 @@
         </p:nvSpPr>
         <p:spPr>
           <a:xfrm>
-            <a:off x="841248" y="4782312"/>
+            <a:off x="841248" y="4764024"/>
             <a:ext cx="4971136" cy="182880"/>
           </a:xfrm>
           <a:prstGeom prst="rect">
@@ -14163,8 +14660,8 @@
         </p:nvSpPr>
         <p:spPr>
           <a:xfrm>
-            <a:off x="841248" y="5010912"/>
-            <a:ext cx="4952848" cy="585216"/>
+            <a:off x="841248" y="4992624"/>
+            <a:ext cx="4952848" cy="548640"/>
           </a:xfrm>
           <a:prstGeom prst="rect">
             <a:avLst/>
@@ -14202,8 +14699,8 @@
         </p:nvSpPr>
         <p:spPr>
           <a:xfrm>
-            <a:off x="6214720" y="4681728"/>
-            <a:ext cx="5318608" cy="987552"/>
+            <a:off x="6214720" y="4663440"/>
+            <a:ext cx="5318608" cy="950976"/>
           </a:xfrm>
           <a:prstGeom prst="roundRect">
             <a:avLst>
@@ -14248,8 +14745,8 @@
         </p:nvSpPr>
         <p:spPr>
           <a:xfrm>
-            <a:off x="6214720" y="4681728"/>
-            <a:ext cx="41148" cy="987552"/>
+            <a:off x="6214720" y="4663440"/>
+            <a:ext cx="41148" cy="950976"/>
           </a:xfrm>
           <a:prstGeom prst="rect">
             <a:avLst/>
@@ -14292,7 +14789,7 @@
         </p:nvSpPr>
         <p:spPr>
           <a:xfrm>
-            <a:off x="6397600" y="4782312"/>
+            <a:off x="6397600" y="4764024"/>
             <a:ext cx="4971136" cy="182880"/>
           </a:xfrm>
           <a:prstGeom prst="rect">
@@ -14340,8 +14837,8 @@
         </p:nvSpPr>
         <p:spPr>
           <a:xfrm>
-            <a:off x="6397600" y="5010912"/>
-            <a:ext cx="4952848" cy="585216"/>
+            <a:off x="6397600" y="4992624"/>
+            <a:ext cx="4952848" cy="548640"/>
           </a:xfrm>
           <a:prstGeom prst="rect">
             <a:avLst/>
@@ -14379,7 +14876,7 @@
         </p:nvSpPr>
         <p:spPr>
           <a:xfrm>
-            <a:off x="658368" y="5687568"/>
+            <a:off x="658368" y="5724144"/>
             <a:ext cx="10874959" cy="402336"/>
           </a:xfrm>
           <a:prstGeom prst="roundRect">
@@ -14425,7 +14922,7 @@
         </p:nvSpPr>
         <p:spPr>
           <a:xfrm>
-            <a:off x="658368" y="5687568"/>
+            <a:off x="658368" y="5724144"/>
             <a:ext cx="45720" cy="402336"/>
           </a:xfrm>
           <a:prstGeom prst="rect">
@@ -14469,7 +14966,7 @@
         </p:nvSpPr>
         <p:spPr>
           <a:xfrm>
-            <a:off x="841248" y="5687568"/>
+            <a:off x="841248" y="5724144"/>
             <a:ext cx="10509199" cy="402336"/>
           </a:xfrm>
           <a:prstGeom prst="rect">
@@ -14771,7 +15268,7 @@
         <p:spPr>
           <a:xfrm>
             <a:off x="658368" y="310896"/>
-            <a:ext cx="6035040" cy="182880"/>
+            <a:ext cx="5669280" cy="182880"/>
           </a:xfrm>
           <a:prstGeom prst="rect">
             <a:avLst/>
@@ -14809,8 +15306,8 @@
         </p:nvSpPr>
         <p:spPr>
           <a:xfrm>
-            <a:off x="7327087" y="310896"/>
-            <a:ext cx="4206240" cy="182880"/>
+            <a:off x="6595567" y="310896"/>
+            <a:ext cx="4937760" cy="182880"/>
           </a:xfrm>
           <a:prstGeom prst="rect">
             <a:avLst/>
@@ -14835,7 +15332,7 @@
                 </a:solidFill>
                 <a:latin typeface="Calibri"/>
               </a:rPr>
-              <a:t>LECTURE LINK · SESSIONS 5–9</a:t>
+              <a:t>SESSIONS 5–9 · RECAP</a:t>
             </a:r>
           </a:p>
         </p:txBody>
@@ -16984,7 +17481,7 @@
         <p:spPr>
           <a:xfrm>
             <a:off x="658368" y="310896"/>
-            <a:ext cx="6035040" cy="182880"/>
+            <a:ext cx="5669280" cy="182880"/>
           </a:xfrm>
           <a:prstGeom prst="rect">
             <a:avLst/>
@@ -17288,7 +17785,7 @@
         <p:spPr>
           <a:xfrm>
             <a:off x="658368" y="1671325"/>
-            <a:ext cx="10874959" cy="308153"/>
+            <a:ext cx="10874959" cy="370332"/>
           </a:xfrm>
           <a:prstGeom prst="rect">
             <a:avLst/>
@@ -17332,7 +17829,7 @@
         <p:spPr>
           <a:xfrm>
             <a:off x="786384" y="1712473"/>
-            <a:ext cx="4343400" cy="248717"/>
+            <a:ext cx="4343400" cy="310896"/>
           </a:xfrm>
           <a:prstGeom prst="rect">
             <a:avLst/>
@@ -17371,7 +17868,7 @@
         <p:spPr>
           <a:xfrm>
             <a:off x="5321808" y="1712473"/>
-            <a:ext cx="4572000" cy="248717"/>
+            <a:ext cx="4572000" cy="310896"/>
           </a:xfrm>
           <a:prstGeom prst="rect">
             <a:avLst/>
@@ -17410,7 +17907,7 @@
         <p:spPr>
           <a:xfrm>
             <a:off x="9985248" y="1712473"/>
-            <a:ext cx="1463040" cy="248717"/>
+            <a:ext cx="1463040" cy="310896"/>
           </a:xfrm>
           <a:prstGeom prst="rect">
             <a:avLst/>
@@ -17448,8 +17945,8 @@
         </p:nvSpPr>
         <p:spPr>
           <a:xfrm>
-            <a:off x="786384" y="2034342"/>
-            <a:ext cx="4343400" cy="248717"/>
+            <a:off x="786384" y="2096521"/>
+            <a:ext cx="4343400" cy="310896"/>
           </a:xfrm>
           <a:prstGeom prst="rect">
             <a:avLst/>
@@ -17487,8 +17984,8 @@
         </p:nvSpPr>
         <p:spPr>
           <a:xfrm>
-            <a:off x="5321808" y="2034342"/>
-            <a:ext cx="4572000" cy="248717"/>
+            <a:off x="5321808" y="2096521"/>
+            <a:ext cx="4572000" cy="310896"/>
           </a:xfrm>
           <a:prstGeom prst="rect">
             <a:avLst/>
@@ -17526,8 +18023,8 @@
         </p:nvSpPr>
         <p:spPr>
           <a:xfrm>
-            <a:off x="9985248" y="2034342"/>
-            <a:ext cx="1463040" cy="248717"/>
+            <a:off x="9985248" y="2096521"/>
+            <a:ext cx="1463040" cy="310896"/>
           </a:xfrm>
           <a:prstGeom prst="rect">
             <a:avLst/>
@@ -17565,8 +18062,8 @@
         </p:nvSpPr>
         <p:spPr>
           <a:xfrm>
-            <a:off x="658368" y="2315063"/>
-            <a:ext cx="10874959" cy="308153"/>
+            <a:off x="658368" y="2439421"/>
+            <a:ext cx="10874959" cy="370332"/>
           </a:xfrm>
           <a:prstGeom prst="rect">
             <a:avLst/>
@@ -17609,8 +18106,8 @@
         </p:nvSpPr>
         <p:spPr>
           <a:xfrm>
-            <a:off x="786384" y="2356211"/>
-            <a:ext cx="4343400" cy="248717"/>
+            <a:off x="786384" y="2480569"/>
+            <a:ext cx="4343400" cy="310896"/>
           </a:xfrm>
           <a:prstGeom prst="rect">
             <a:avLst/>
@@ -17648,8 +18145,8 @@
         </p:nvSpPr>
         <p:spPr>
           <a:xfrm>
-            <a:off x="5321808" y="2356211"/>
-            <a:ext cx="4572000" cy="248717"/>
+            <a:off x="5321808" y="2480569"/>
+            <a:ext cx="4572000" cy="310896"/>
           </a:xfrm>
           <a:prstGeom prst="rect">
             <a:avLst/>
@@ -17687,8 +18184,8 @@
         </p:nvSpPr>
         <p:spPr>
           <a:xfrm>
-            <a:off x="9985248" y="2356211"/>
-            <a:ext cx="1463040" cy="248717"/>
+            <a:off x="9985248" y="2480569"/>
+            <a:ext cx="1463040" cy="310896"/>
           </a:xfrm>
           <a:prstGeom prst="rect">
             <a:avLst/>
@@ -17726,8 +18223,8 @@
         </p:nvSpPr>
         <p:spPr>
           <a:xfrm>
-            <a:off x="786384" y="2678079"/>
-            <a:ext cx="4343400" cy="248717"/>
+            <a:off x="786384" y="2864617"/>
+            <a:ext cx="4343400" cy="310896"/>
           </a:xfrm>
           <a:prstGeom prst="rect">
             <a:avLst/>
@@ -17765,8 +18262,8 @@
         </p:nvSpPr>
         <p:spPr>
           <a:xfrm>
-            <a:off x="5321808" y="2678079"/>
-            <a:ext cx="4572000" cy="248717"/>
+            <a:off x="5321808" y="2864617"/>
+            <a:ext cx="4572000" cy="310896"/>
           </a:xfrm>
           <a:prstGeom prst="rect">
             <a:avLst/>
@@ -17804,8 +18301,8 @@
         </p:nvSpPr>
         <p:spPr>
           <a:xfrm>
-            <a:off x="9985248" y="2678079"/>
-            <a:ext cx="1463040" cy="248717"/>
+            <a:off x="9985248" y="2864617"/>
+            <a:ext cx="1463040" cy="310896"/>
           </a:xfrm>
           <a:prstGeom prst="rect">
             <a:avLst/>
@@ -17843,8 +18340,8 @@
         </p:nvSpPr>
         <p:spPr>
           <a:xfrm>
-            <a:off x="658368" y="2958800"/>
-            <a:ext cx="10874959" cy="308153"/>
+            <a:off x="658368" y="3207517"/>
+            <a:ext cx="10874959" cy="370332"/>
           </a:xfrm>
           <a:prstGeom prst="rect">
             <a:avLst/>
@@ -17887,8 +18384,8 @@
         </p:nvSpPr>
         <p:spPr>
           <a:xfrm>
-            <a:off x="786384" y="2999948"/>
-            <a:ext cx="4343400" cy="248717"/>
+            <a:off x="786384" y="3248665"/>
+            <a:ext cx="4343400" cy="310896"/>
           </a:xfrm>
           <a:prstGeom prst="rect">
             <a:avLst/>
@@ -17926,8 +18423,8 @@
         </p:nvSpPr>
         <p:spPr>
           <a:xfrm>
-            <a:off x="5321808" y="2999948"/>
-            <a:ext cx="4572000" cy="248717"/>
+            <a:off x="5321808" y="3248665"/>
+            <a:ext cx="4572000" cy="310896"/>
           </a:xfrm>
           <a:prstGeom prst="rect">
             <a:avLst/>
@@ -17965,8 +18462,8 @@
         </p:nvSpPr>
         <p:spPr>
           <a:xfrm>
-            <a:off x="9985248" y="2999948"/>
-            <a:ext cx="1463040" cy="248717"/>
+            <a:off x="9985248" y="3248665"/>
+            <a:ext cx="1463040" cy="310896"/>
           </a:xfrm>
           <a:prstGeom prst="rect">
             <a:avLst/>
@@ -18004,8 +18501,8 @@
         </p:nvSpPr>
         <p:spPr>
           <a:xfrm>
-            <a:off x="786384" y="3321817"/>
-            <a:ext cx="4343400" cy="248717"/>
+            <a:off x="786384" y="3632713"/>
+            <a:ext cx="4343400" cy="310896"/>
           </a:xfrm>
           <a:prstGeom prst="rect">
             <a:avLst/>
@@ -18043,8 +18540,8 @@
         </p:nvSpPr>
         <p:spPr>
           <a:xfrm>
-            <a:off x="5321808" y="3321817"/>
-            <a:ext cx="4572000" cy="248717"/>
+            <a:off x="5321808" y="3632713"/>
+            <a:ext cx="4572000" cy="310896"/>
           </a:xfrm>
           <a:prstGeom prst="rect">
             <a:avLst/>
@@ -18082,8 +18579,8 @@
         </p:nvSpPr>
         <p:spPr>
           <a:xfrm>
-            <a:off x="9985248" y="3321817"/>
-            <a:ext cx="1463040" cy="248717"/>
+            <a:off x="9985248" y="3632713"/>
+            <a:ext cx="1463040" cy="310896"/>
           </a:xfrm>
           <a:prstGeom prst="rect">
             <a:avLst/>
@@ -18121,8 +18618,8 @@
         </p:nvSpPr>
         <p:spPr>
           <a:xfrm>
-            <a:off x="658368" y="3602538"/>
-            <a:ext cx="10874959" cy="308153"/>
+            <a:off x="658368" y="3975613"/>
+            <a:ext cx="10874959" cy="370332"/>
           </a:xfrm>
           <a:prstGeom prst="rect">
             <a:avLst/>
@@ -18165,8 +18662,8 @@
         </p:nvSpPr>
         <p:spPr>
           <a:xfrm>
-            <a:off x="786384" y="3643686"/>
-            <a:ext cx="4343400" cy="248717"/>
+            <a:off x="786384" y="4016761"/>
+            <a:ext cx="4343400" cy="310896"/>
           </a:xfrm>
           <a:prstGeom prst="rect">
             <a:avLst/>
@@ -18204,8 +18701,8 @@
         </p:nvSpPr>
         <p:spPr>
           <a:xfrm>
-            <a:off x="5321808" y="3643686"/>
-            <a:ext cx="4572000" cy="248717"/>
+            <a:off x="5321808" y="4016761"/>
+            <a:ext cx="4572000" cy="310896"/>
           </a:xfrm>
           <a:prstGeom prst="rect">
             <a:avLst/>
@@ -18243,8 +18740,8 @@
         </p:nvSpPr>
         <p:spPr>
           <a:xfrm>
-            <a:off x="9985248" y="3643686"/>
-            <a:ext cx="1463040" cy="248717"/>
+            <a:off x="9985248" y="4016761"/>
+            <a:ext cx="1463040" cy="310896"/>
           </a:xfrm>
           <a:prstGeom prst="rect">
             <a:avLst/>
@@ -18282,8 +18779,8 @@
         </p:nvSpPr>
         <p:spPr>
           <a:xfrm>
-            <a:off x="786384" y="3965555"/>
-            <a:ext cx="4343400" cy="248717"/>
+            <a:off x="786384" y="4400809"/>
+            <a:ext cx="4343400" cy="310896"/>
           </a:xfrm>
           <a:prstGeom prst="rect">
             <a:avLst/>
@@ -18321,8 +18818,8 @@
         </p:nvSpPr>
         <p:spPr>
           <a:xfrm>
-            <a:off x="5321808" y="3965555"/>
-            <a:ext cx="4572000" cy="248717"/>
+            <a:off x="5321808" y="4400809"/>
+            <a:ext cx="4572000" cy="310896"/>
           </a:xfrm>
           <a:prstGeom prst="rect">
             <a:avLst/>
@@ -18360,8 +18857,8 @@
         </p:nvSpPr>
         <p:spPr>
           <a:xfrm>
-            <a:off x="9985248" y="3965555"/>
-            <a:ext cx="1463040" cy="248717"/>
+            <a:off x="9985248" y="4400809"/>
+            <a:ext cx="1463040" cy="310896"/>
           </a:xfrm>
           <a:prstGeom prst="rect">
             <a:avLst/>
@@ -18399,8 +18896,8 @@
         </p:nvSpPr>
         <p:spPr>
           <a:xfrm>
-            <a:off x="658368" y="4246275"/>
-            <a:ext cx="10874959" cy="308153"/>
+            <a:off x="658368" y="4743709"/>
+            <a:ext cx="10874959" cy="370332"/>
           </a:xfrm>
           <a:prstGeom prst="rect">
             <a:avLst/>
@@ -18443,8 +18940,8 @@
         </p:nvSpPr>
         <p:spPr>
           <a:xfrm>
-            <a:off x="786384" y="4287423"/>
-            <a:ext cx="4343400" cy="248717"/>
+            <a:off x="786384" y="4784857"/>
+            <a:ext cx="4343400" cy="310896"/>
           </a:xfrm>
           <a:prstGeom prst="rect">
             <a:avLst/>
@@ -18482,8 +18979,8 @@
         </p:nvSpPr>
         <p:spPr>
           <a:xfrm>
-            <a:off x="5321808" y="4287423"/>
-            <a:ext cx="4572000" cy="248717"/>
+            <a:off x="5321808" y="4784857"/>
+            <a:ext cx="4572000" cy="310896"/>
           </a:xfrm>
           <a:prstGeom prst="rect">
             <a:avLst/>
@@ -18521,8 +19018,8 @@
         </p:nvSpPr>
         <p:spPr>
           <a:xfrm>
-            <a:off x="9985248" y="4287423"/>
-            <a:ext cx="1463040" cy="248717"/>
+            <a:off x="9985248" y="4784857"/>
+            <a:ext cx="1463040" cy="310896"/>
           </a:xfrm>
           <a:prstGeom prst="rect">
             <a:avLst/>
@@ -18560,8 +19057,8 @@
         </p:nvSpPr>
         <p:spPr>
           <a:xfrm>
-            <a:off x="786384" y="4609292"/>
-            <a:ext cx="4343400" cy="248717"/>
+            <a:off x="786384" y="5168905"/>
+            <a:ext cx="4343400" cy="310896"/>
           </a:xfrm>
           <a:prstGeom prst="rect">
             <a:avLst/>
@@ -18599,8 +19096,8 @@
         </p:nvSpPr>
         <p:spPr>
           <a:xfrm>
-            <a:off x="5321808" y="4609292"/>
-            <a:ext cx="4572000" cy="248717"/>
+            <a:off x="5321808" y="5168905"/>
+            <a:ext cx="4572000" cy="310896"/>
           </a:xfrm>
           <a:prstGeom prst="rect">
             <a:avLst/>
@@ -18638,8 +19135,8 @@
         </p:nvSpPr>
         <p:spPr>
           <a:xfrm>
-            <a:off x="9985248" y="4609292"/>
-            <a:ext cx="1463040" cy="248717"/>
+            <a:off x="9985248" y="5168905"/>
+            <a:ext cx="1463040" cy="310896"/>
           </a:xfrm>
           <a:prstGeom prst="rect">
             <a:avLst/>
@@ -18677,8 +19174,8 @@
         </p:nvSpPr>
         <p:spPr>
           <a:xfrm>
-            <a:off x="658368" y="4890013"/>
-            <a:ext cx="10874959" cy="308153"/>
+            <a:off x="658368" y="5511805"/>
+            <a:ext cx="10874959" cy="370332"/>
           </a:xfrm>
           <a:prstGeom prst="rect">
             <a:avLst/>
@@ -18721,8 +19218,8 @@
         </p:nvSpPr>
         <p:spPr>
           <a:xfrm>
-            <a:off x="786384" y="4931161"/>
-            <a:ext cx="4343400" cy="248717"/>
+            <a:off x="786384" y="5552953"/>
+            <a:ext cx="4343400" cy="310896"/>
           </a:xfrm>
           <a:prstGeom prst="rect">
             <a:avLst/>
@@ -18760,8 +19257,8 @@
         </p:nvSpPr>
         <p:spPr>
           <a:xfrm>
-            <a:off x="5321808" y="4931161"/>
-            <a:ext cx="4572000" cy="248717"/>
+            <a:off x="5321808" y="5552953"/>
+            <a:ext cx="4572000" cy="310896"/>
           </a:xfrm>
           <a:prstGeom prst="rect">
             <a:avLst/>
@@ -18799,8 +19296,8 @@
         </p:nvSpPr>
         <p:spPr>
           <a:xfrm>
-            <a:off x="9985248" y="4931161"/>
-            <a:ext cx="1463040" cy="248717"/>
+            <a:off x="9985248" y="5552953"/>
+            <a:ext cx="1463040" cy="310896"/>
           </a:xfrm>
           <a:prstGeom prst="rect">
             <a:avLst/>
@@ -18838,8 +19335,8 @@
         </p:nvSpPr>
         <p:spPr>
           <a:xfrm>
-            <a:off x="786384" y="5253030"/>
-            <a:ext cx="4343400" cy="248717"/>
+            <a:off x="786384" y="5937001"/>
+            <a:ext cx="4343400" cy="310896"/>
           </a:xfrm>
           <a:prstGeom prst="rect">
             <a:avLst/>
@@ -18877,8 +19374,8 @@
         </p:nvSpPr>
         <p:spPr>
           <a:xfrm>
-            <a:off x="5321808" y="5253030"/>
-            <a:ext cx="4572000" cy="248717"/>
+            <a:off x="5321808" y="5937001"/>
+            <a:ext cx="4572000" cy="310896"/>
           </a:xfrm>
           <a:prstGeom prst="rect">
             <a:avLst/>
@@ -18916,8 +19413,8 @@
         </p:nvSpPr>
         <p:spPr>
           <a:xfrm>
-            <a:off x="9985248" y="5253030"/>
-            <a:ext cx="1463040" cy="248717"/>
+            <a:off x="9985248" y="5937001"/>
+            <a:ext cx="1463040" cy="310896"/>
           </a:xfrm>
           <a:prstGeom prst="rect">
             <a:avLst/>
@@ -19209,7 +19706,7 @@
         <p:spPr>
           <a:xfrm>
             <a:off x="658368" y="310896"/>
-            <a:ext cx="6035040" cy="182880"/>
+            <a:ext cx="5669280" cy="182880"/>
           </a:xfrm>
           <a:prstGeom prst="rect">
             <a:avLst/>
@@ -19556,7 +20053,7 @@
         </p:nvCxnSpPr>
         <p:spPr>
           <a:xfrm>
-            <a:off x="658368" y="2206249"/>
+            <a:off x="658368" y="2169673"/>
             <a:ext cx="5760720" cy="0"/>
           </a:xfrm>
           <a:prstGeom prst="line">
@@ -19591,7 +20088,7 @@
         </p:nvSpPr>
         <p:spPr>
           <a:xfrm>
-            <a:off x="658368" y="2334265"/>
+            <a:off x="658368" y="2297689"/>
             <a:ext cx="868680" cy="182880"/>
           </a:xfrm>
           <a:prstGeom prst="rect">
@@ -19630,7 +20127,7 @@
         </p:nvSpPr>
         <p:spPr>
           <a:xfrm>
-            <a:off x="1591056" y="2306833"/>
+            <a:off x="1591056" y="2270257"/>
             <a:ext cx="4828032" cy="201168"/>
           </a:xfrm>
           <a:prstGeom prst="rect">
@@ -19669,7 +20166,7 @@
         </p:nvSpPr>
         <p:spPr>
           <a:xfrm>
-            <a:off x="1591056" y="2508001"/>
+            <a:off x="1591056" y="2471425"/>
             <a:ext cx="4828032" cy="182880"/>
           </a:xfrm>
           <a:prstGeom prst="rect">
@@ -19708,7 +20205,7 @@
         </p:nvSpPr>
         <p:spPr>
           <a:xfrm>
-            <a:off x="1591056" y="2681737"/>
+            <a:off x="1591056" y="2645161"/>
             <a:ext cx="4828032" cy="164592"/>
           </a:xfrm>
           <a:prstGeom prst="rect">
@@ -19748,7 +20245,7 @@
         </p:nvCxnSpPr>
         <p:spPr>
           <a:xfrm>
-            <a:off x="658368" y="2864617"/>
+            <a:off x="658368" y="2791465"/>
             <a:ext cx="5760720" cy="0"/>
           </a:xfrm>
           <a:prstGeom prst="line">
@@ -19783,7 +20280,7 @@
         </p:nvSpPr>
         <p:spPr>
           <a:xfrm>
-            <a:off x="658368" y="2992633"/>
+            <a:off x="658368" y="2919481"/>
             <a:ext cx="868680" cy="182880"/>
           </a:xfrm>
           <a:prstGeom prst="rect">
@@ -19822,7 +20319,7 @@
         </p:nvSpPr>
         <p:spPr>
           <a:xfrm>
-            <a:off x="1591056" y="2965201"/>
+            <a:off x="1591056" y="2892049"/>
             <a:ext cx="4828032" cy="201168"/>
           </a:xfrm>
           <a:prstGeom prst="rect">
@@ -19861,7 +20358,7 @@
         </p:nvSpPr>
         <p:spPr>
           <a:xfrm>
-            <a:off x="1591056" y="3166369"/>
+            <a:off x="1591056" y="3093217"/>
             <a:ext cx="4828032" cy="182880"/>
           </a:xfrm>
           <a:prstGeom prst="rect">
@@ -19900,7 +20397,7 @@
         </p:nvSpPr>
         <p:spPr>
           <a:xfrm>
-            <a:off x="1591056" y="3340105"/>
+            <a:off x="1591056" y="3266953"/>
             <a:ext cx="4828032" cy="164592"/>
           </a:xfrm>
           <a:prstGeom prst="rect">
@@ -19940,7 +20437,7 @@
         </p:nvCxnSpPr>
         <p:spPr>
           <a:xfrm>
-            <a:off x="658368" y="3522985"/>
+            <a:off x="658368" y="3413257"/>
             <a:ext cx="5760720" cy="0"/>
           </a:xfrm>
           <a:prstGeom prst="line">
@@ -19975,7 +20472,7 @@
         </p:nvSpPr>
         <p:spPr>
           <a:xfrm>
-            <a:off x="658368" y="3651001"/>
+            <a:off x="658368" y="3541273"/>
             <a:ext cx="868680" cy="182880"/>
           </a:xfrm>
           <a:prstGeom prst="rect">
@@ -20014,7 +20511,7 @@
         </p:nvSpPr>
         <p:spPr>
           <a:xfrm>
-            <a:off x="1591056" y="3623569"/>
+            <a:off x="1591056" y="3513841"/>
             <a:ext cx="4828032" cy="201168"/>
           </a:xfrm>
           <a:prstGeom prst="rect">
@@ -20053,7 +20550,7 @@
         </p:nvSpPr>
         <p:spPr>
           <a:xfrm>
-            <a:off x="1591056" y="3824737"/>
+            <a:off x="1591056" y="3715009"/>
             <a:ext cx="4828032" cy="182880"/>
           </a:xfrm>
           <a:prstGeom prst="rect">
@@ -20092,7 +20589,7 @@
         </p:nvSpPr>
         <p:spPr>
           <a:xfrm>
-            <a:off x="1591056" y="3998473"/>
+            <a:off x="1591056" y="3888745"/>
             <a:ext cx="4828032" cy="164592"/>
           </a:xfrm>
           <a:prstGeom prst="rect">
@@ -20132,7 +20629,7 @@
         </p:nvCxnSpPr>
         <p:spPr>
           <a:xfrm>
-            <a:off x="658368" y="4181353"/>
+            <a:off x="658368" y="4035049"/>
             <a:ext cx="5760720" cy="0"/>
           </a:xfrm>
           <a:prstGeom prst="line">
@@ -20167,7 +20664,7 @@
         </p:nvSpPr>
         <p:spPr>
           <a:xfrm>
-            <a:off x="658368" y="4309369"/>
+            <a:off x="658368" y="4163065"/>
             <a:ext cx="868680" cy="182880"/>
           </a:xfrm>
           <a:prstGeom prst="rect">
@@ -20206,7 +20703,7 @@
         </p:nvSpPr>
         <p:spPr>
           <a:xfrm>
-            <a:off x="1591056" y="4281937"/>
+            <a:off x="1591056" y="4135633"/>
             <a:ext cx="4828032" cy="201168"/>
           </a:xfrm>
           <a:prstGeom prst="rect">
@@ -20245,7 +20742,7 @@
         </p:nvSpPr>
         <p:spPr>
           <a:xfrm>
-            <a:off x="1591056" y="4483105"/>
+            <a:off x="1591056" y="4336801"/>
             <a:ext cx="4828032" cy="182880"/>
           </a:xfrm>
           <a:prstGeom prst="rect">
@@ -20284,7 +20781,7 @@
         </p:nvSpPr>
         <p:spPr>
           <a:xfrm>
-            <a:off x="1591056" y="4656841"/>
+            <a:off x="1591056" y="4510537"/>
             <a:ext cx="4828032" cy="164592"/>
           </a:xfrm>
           <a:prstGeom prst="rect">
@@ -20324,7 +20821,7 @@
         </p:nvCxnSpPr>
         <p:spPr>
           <a:xfrm>
-            <a:off x="658368" y="4839721"/>
+            <a:off x="658368" y="4656841"/>
             <a:ext cx="5760720" cy="0"/>
           </a:xfrm>
           <a:prstGeom prst="line">
@@ -21374,8 +21871,509 @@
         </p:nvSpPr>
         <p:spPr>
           <a:xfrm>
-            <a:off x="7059168" y="3961897"/>
-            <a:ext cx="4474159" cy="960120"/>
+            <a:off x="658368" y="4967737"/>
+            <a:ext cx="5760720" cy="896112"/>
+          </a:xfrm>
+          <a:prstGeom prst="roundRect">
+            <a:avLst>
+              <a:gd name="adj" fmla="val 4000"/>
+            </a:avLst>
+          </a:prstGeom>
+          <a:solidFill>
+            <a:srgbClr val="ECF2FA"/>
+          </a:solidFill>
+          <a:ln w="7620">
+            <a:solidFill>
+              <a:srgbClr val="C9DCF0"/>
+            </a:solidFill>
+          </a:ln>
+          <a:effectLst/>
+        </p:spPr>
+        <p:style>
+          <a:lnRef idx="1">
+            <a:schemeClr val="accent1"/>
+          </a:lnRef>
+          <a:fillRef idx="3">
+            <a:schemeClr val="accent1"/>
+          </a:fillRef>
+          <a:effectRef idx="2">
+            <a:schemeClr val="accent1"/>
+          </a:effectRef>
+          <a:fontRef idx="minor">
+            <a:schemeClr val="lt1"/>
+          </a:fontRef>
+        </p:style>
+        <p:txBody>
+          <a:bodyPr rtlCol="0" anchor="ctr" wrap="square"/>
+          <a:lstStyle/>
+          <a:p>
+            <a:pPr algn="ctr"/>
+          </a:p>
+        </p:txBody>
+      </p:sp>
+      <p:sp>
+        <p:nvSpPr>
+          <p:cNvPr id="59" name="Rectangle 58"/>
+          <p:cNvSpPr/>
+          <p:nvPr/>
+        </p:nvSpPr>
+        <p:spPr>
+          <a:xfrm>
+            <a:off x="658368" y="4967737"/>
+            <a:ext cx="45720" cy="896112"/>
+          </a:xfrm>
+          <a:prstGeom prst="rect">
+            <a:avLst/>
+          </a:prstGeom>
+          <a:solidFill>
+            <a:srgbClr val="2B6CB0"/>
+          </a:solidFill>
+          <a:ln>
+            <a:noFill/>
+          </a:ln>
+          <a:effectLst/>
+        </p:spPr>
+        <p:style>
+          <a:lnRef idx="1">
+            <a:schemeClr val="accent1"/>
+          </a:lnRef>
+          <a:fillRef idx="3">
+            <a:schemeClr val="accent1"/>
+          </a:fillRef>
+          <a:effectRef idx="2">
+            <a:schemeClr val="accent1"/>
+          </a:effectRef>
+          <a:fontRef idx="minor">
+            <a:schemeClr val="lt1"/>
+          </a:fontRef>
+        </p:style>
+        <p:txBody>
+          <a:bodyPr rtlCol="0" anchor="ctr" wrap="square"/>
+          <a:lstStyle/>
+          <a:p>
+            <a:pPr algn="ctr"/>
+          </a:p>
+        </p:txBody>
+      </p:sp>
+      <p:sp>
+        <p:nvSpPr>
+          <p:cNvPr id="60" name="TextBox 59"/>
+          <p:cNvSpPr txBox="1"/>
+          <p:nvPr/>
+        </p:nvSpPr>
+        <p:spPr>
+          <a:xfrm>
+            <a:off x="859536" y="5114041"/>
+            <a:ext cx="5358384" cy="603504"/>
+          </a:xfrm>
+          <a:prstGeom prst="rect">
+            <a:avLst/>
+          </a:prstGeom>
+          <a:noFill/>
+        </p:spPr>
+        <p:txBody>
+          <a:bodyPr wrap="square" lIns="0" rIns="0" tIns="0" bIns="0" anchor="t">
+            <a:noAutofit/>
+          </a:bodyPr>
+          <a:lstStyle/>
+          <a:p>
+            <a:pPr algn="l">
+              <a:lnSpc>
+                <a:spcPct val="100000"/>
+              </a:lnSpc>
+            </a:pPr>
+            <a:r>
+              <a:rPr sz="720" b="1" i="0" spc="100">
+                <a:solidFill>
+                  <a:srgbClr val="2B6CB0"/>
+                </a:solidFill>
+                <a:latin typeface="Calibri"/>
+              </a:rPr>
+              <a:t>DECLARATION</a:t>
+            </a:r>
+          </a:p>
+          <a:p>
+            <a:pPr algn="l">
+              <a:lnSpc>
+                <a:spcPct val="126000"/>
+              </a:lnSpc>
+              <a:spcBef>
+                <a:spcPts val="400"/>
+              </a:spcBef>
+            </a:pPr>
+            <a:r>
+              <a:rPr sz="840" b="0" i="0">
+                <a:solidFill>
+                  <a:srgbClr val="44546A"/>
+                </a:solidFill>
+                <a:latin typeface="Calibri"/>
+              </a:rPr>
+              <a:t>This assignment is my own work, prepared from the recorded sessions and the case brief, and is submitted on or before the deadline set in Google Classroom.</a:t>
+            </a:r>
+          </a:p>
+        </p:txBody>
+      </p:sp>
+      <p:sp>
+        <p:nvSpPr>
+          <p:cNvPr id="61" name="TextBox 60"/>
+          <p:cNvSpPr txBox="1"/>
+          <p:nvPr/>
+        </p:nvSpPr>
+        <p:spPr>
+          <a:xfrm>
+            <a:off x="7059168" y="3998473"/>
+            <a:ext cx="4474159" cy="182880"/>
+          </a:xfrm>
+          <a:prstGeom prst="rect">
+            <a:avLst/>
+          </a:prstGeom>
+          <a:noFill/>
+        </p:spPr>
+        <p:txBody>
+          <a:bodyPr wrap="square" lIns="0" rIns="0" tIns="0" bIns="0" anchor="t">
+            <a:noAutofit/>
+          </a:bodyPr>
+          <a:lstStyle/>
+          <a:p>
+            <a:pPr algn="l">
+              <a:lnSpc>
+                <a:spcPct val="100000"/>
+              </a:lnSpc>
+            </a:pPr>
+            <a:r>
+              <a:rPr sz="760" b="1" i="0" spc="110">
+                <a:solidFill>
+                  <a:srgbClr val="2B6CB0"/>
+                </a:solidFill>
+                <a:latin typeface="Calibri"/>
+              </a:rPr>
+              <a:t>THE WHOLE ARGUMENT IN FOUR LINES</a:t>
+            </a:r>
+          </a:p>
+        </p:txBody>
+      </p:sp>
+      <p:sp>
+        <p:nvSpPr>
+          <p:cNvPr id="62" name="TextBox 61"/>
+          <p:cNvSpPr txBox="1"/>
+          <p:nvPr/>
+        </p:nvSpPr>
+        <p:spPr>
+          <a:xfrm>
+            <a:off x="7059168" y="4236217"/>
+            <a:ext cx="859536" cy="182880"/>
+          </a:xfrm>
+          <a:prstGeom prst="rect">
+            <a:avLst/>
+          </a:prstGeom>
+          <a:noFill/>
+        </p:spPr>
+        <p:txBody>
+          <a:bodyPr wrap="square" lIns="0" rIns="0" tIns="0" bIns="0" anchor="t">
+            <a:noAutofit/>
+          </a:bodyPr>
+          <a:lstStyle/>
+          <a:p>
+            <a:pPr algn="l">
+              <a:lnSpc>
+                <a:spcPct val="115000"/>
+              </a:lnSpc>
+            </a:pPr>
+            <a:r>
+              <a:rPr sz="860" b="1" i="0">
+                <a:solidFill>
+                  <a:srgbClr val="12263F"/>
+                </a:solidFill>
+                <a:latin typeface="Calibri"/>
+              </a:rPr>
+              <a:t>Market</a:t>
+            </a:r>
+          </a:p>
+        </p:txBody>
+      </p:sp>
+      <p:sp>
+        <p:nvSpPr>
+          <p:cNvPr id="63" name="TextBox 62"/>
+          <p:cNvSpPr txBox="1"/>
+          <p:nvPr/>
+        </p:nvSpPr>
+        <p:spPr>
+          <a:xfrm>
+            <a:off x="7973568" y="4236217"/>
+            <a:ext cx="3559759" cy="138141"/>
+          </a:xfrm>
+          <a:prstGeom prst="rect">
+            <a:avLst/>
+          </a:prstGeom>
+          <a:noFill/>
+        </p:spPr>
+        <p:txBody>
+          <a:bodyPr wrap="square" lIns="0" rIns="0" tIns="0" bIns="0" anchor="t">
+            <a:noAutofit/>
+          </a:bodyPr>
+          <a:lstStyle/>
+          <a:p>
+            <a:pPr algn="l">
+              <a:lnSpc>
+                <a:spcPct val="124000"/>
+              </a:lnSpc>
+            </a:pPr>
+            <a:r>
+              <a:rPr sz="860" b="0" i="0">
+                <a:solidFill>
+                  <a:srgbClr val="44546A"/>
+                </a:solidFill>
+                <a:latin typeface="Calibri"/>
+              </a:rPr>
+              <a:t>four firms, 86% share, mutual dependence → oligopoly</a:t>
+            </a:r>
+          </a:p>
+        </p:txBody>
+      </p:sp>
+      <p:sp>
+        <p:nvSpPr>
+          <p:cNvPr id="64" name="TextBox 63"/>
+          <p:cNvSpPr txBox="1"/>
+          <p:nvPr/>
+        </p:nvSpPr>
+        <p:spPr>
+          <a:xfrm>
+            <a:off x="7059168" y="4465799"/>
+            <a:ext cx="859536" cy="182880"/>
+          </a:xfrm>
+          <a:prstGeom prst="rect">
+            <a:avLst/>
+          </a:prstGeom>
+          <a:noFill/>
+        </p:spPr>
+        <p:txBody>
+          <a:bodyPr wrap="square" lIns="0" rIns="0" tIns="0" bIns="0" anchor="t">
+            <a:noAutofit/>
+          </a:bodyPr>
+          <a:lstStyle/>
+          <a:p>
+            <a:pPr algn="l">
+              <a:lnSpc>
+                <a:spcPct val="115000"/>
+              </a:lnSpc>
+            </a:pPr>
+            <a:r>
+              <a:rPr sz="860" b="1" i="0">
+                <a:solidFill>
+                  <a:srgbClr val="12263F"/>
+                </a:solidFill>
+                <a:latin typeface="Calibri"/>
+              </a:rPr>
+              <a:t>Demand</a:t>
+            </a:r>
+          </a:p>
+        </p:txBody>
+      </p:sp>
+      <p:sp>
+        <p:nvSpPr>
+          <p:cNvPr id="65" name="TextBox 64"/>
+          <p:cNvSpPr txBox="1"/>
+          <p:nvPr/>
+        </p:nvSpPr>
+        <p:spPr>
+          <a:xfrm>
+            <a:off x="7973568" y="4465799"/>
+            <a:ext cx="3559759" cy="138141"/>
+          </a:xfrm>
+          <a:prstGeom prst="rect">
+            <a:avLst/>
+          </a:prstGeom>
+          <a:noFill/>
+        </p:spPr>
+        <p:txBody>
+          <a:bodyPr wrap="square" lIns="0" rIns="0" tIns="0" bIns="0" anchor="t">
+            <a:noAutofit/>
+          </a:bodyPr>
+          <a:lstStyle/>
+          <a:p>
+            <a:pPr algn="l">
+              <a:lnSpc>
+                <a:spcPct val="124000"/>
+              </a:lnSpc>
+            </a:pPr>
+            <a:r>
+              <a:rPr sz="860" b="0" i="0">
+                <a:solidFill>
+                  <a:srgbClr val="44546A"/>
+                </a:solidFill>
+                <a:latin typeface="Calibri"/>
+              </a:rPr>
+              <a:t>petrol is a complement, so higher petrol shifts our demand right</a:t>
+            </a:r>
+          </a:p>
+        </p:txBody>
+      </p:sp>
+      <p:sp>
+        <p:nvSpPr>
+          <p:cNvPr id="66" name="TextBox 65"/>
+          <p:cNvSpPr txBox="1"/>
+          <p:nvPr/>
+        </p:nvSpPr>
+        <p:spPr>
+          <a:xfrm>
+            <a:off x="7059168" y="4695380"/>
+            <a:ext cx="859536" cy="182880"/>
+          </a:xfrm>
+          <a:prstGeom prst="rect">
+            <a:avLst/>
+          </a:prstGeom>
+          <a:noFill/>
+        </p:spPr>
+        <p:txBody>
+          <a:bodyPr wrap="square" lIns="0" rIns="0" tIns="0" bIns="0" anchor="t">
+            <a:noAutofit/>
+          </a:bodyPr>
+          <a:lstStyle/>
+          <a:p>
+            <a:pPr algn="l">
+              <a:lnSpc>
+                <a:spcPct val="115000"/>
+              </a:lnSpc>
+            </a:pPr>
+            <a:r>
+              <a:rPr sz="860" b="1" i="0">
+                <a:solidFill>
+                  <a:srgbClr val="12263F"/>
+                </a:solidFill>
+                <a:latin typeface="Calibri"/>
+              </a:rPr>
+              <a:t>Pricing</a:t>
+            </a:r>
+          </a:p>
+        </p:txBody>
+      </p:sp>
+      <p:sp>
+        <p:nvSpPr>
+          <p:cNvPr id="67" name="TextBox 66"/>
+          <p:cNvSpPr txBox="1"/>
+          <p:nvPr/>
+        </p:nvSpPr>
+        <p:spPr>
+          <a:xfrm>
+            <a:off x="7973568" y="4695380"/>
+            <a:ext cx="3559759" cy="138141"/>
+          </a:xfrm>
+          <a:prstGeom prst="rect">
+            <a:avLst/>
+          </a:prstGeom>
+          <a:noFill/>
+        </p:spPr>
+        <p:txBody>
+          <a:bodyPr wrap="square" lIns="0" rIns="0" tIns="0" bIns="0" anchor="t">
+            <a:noAutofit/>
+          </a:bodyPr>
+          <a:lstStyle/>
+          <a:p>
+            <a:pPr algn="l">
+              <a:lnSpc>
+                <a:spcPct val="124000"/>
+              </a:lnSpc>
+            </a:pPr>
+            <a:r>
+              <a:rPr sz="860" b="0" i="0">
+                <a:solidFill>
+                  <a:srgbClr val="44546A"/>
+                </a:solidFill>
+                <a:latin typeface="Calibri"/>
+              </a:rPr>
+              <a:t>penetration at ₹74,999; rivals match, margin settles lower</a:t>
+            </a:r>
+          </a:p>
+        </p:txBody>
+      </p:sp>
+      <p:sp>
+        <p:nvSpPr>
+          <p:cNvPr id="68" name="TextBox 67"/>
+          <p:cNvSpPr txBox="1"/>
+          <p:nvPr/>
+        </p:nvSpPr>
+        <p:spPr>
+          <a:xfrm>
+            <a:off x="7059168" y="4924961"/>
+            <a:ext cx="859536" cy="182880"/>
+          </a:xfrm>
+          <a:prstGeom prst="rect">
+            <a:avLst/>
+          </a:prstGeom>
+          <a:noFill/>
+        </p:spPr>
+        <p:txBody>
+          <a:bodyPr wrap="square" lIns="0" rIns="0" tIns="0" bIns="0" anchor="t">
+            <a:noAutofit/>
+          </a:bodyPr>
+          <a:lstStyle/>
+          <a:p>
+            <a:pPr algn="l">
+              <a:lnSpc>
+                <a:spcPct val="115000"/>
+              </a:lnSpc>
+            </a:pPr>
+            <a:r>
+              <a:rPr sz="860" b="1" i="0">
+                <a:solidFill>
+                  <a:srgbClr val="12263F"/>
+                </a:solidFill>
+                <a:latin typeface="Calibri"/>
+              </a:rPr>
+              <a:t>Capital</a:t>
+            </a:r>
+          </a:p>
+        </p:txBody>
+      </p:sp>
+      <p:sp>
+        <p:nvSpPr>
+          <p:cNvPr id="69" name="TextBox 68"/>
+          <p:cNvSpPr txBox="1"/>
+          <p:nvPr/>
+        </p:nvSpPr>
+        <p:spPr>
+          <a:xfrm>
+            <a:off x="7973568" y="4924961"/>
+            <a:ext cx="3559759" cy="138141"/>
+          </a:xfrm>
+          <a:prstGeom prst="rect">
+            <a:avLst/>
+          </a:prstGeom>
+          <a:noFill/>
+        </p:spPr>
+        <p:txBody>
+          <a:bodyPr wrap="square" lIns="0" rIns="0" tIns="0" bIns="0" anchor="t">
+            <a:noAutofit/>
+          </a:bodyPr>
+          <a:lstStyle/>
+          <a:p>
+            <a:pPr algn="l">
+              <a:lnSpc>
+                <a:spcPct val="124000"/>
+              </a:lnSpc>
+            </a:pPr>
+            <a:r>
+              <a:rPr sz="860" b="0" i="0">
+                <a:solidFill>
+                  <a:srgbClr val="44546A"/>
+                </a:solidFill>
+                <a:latin typeface="Calibri"/>
+              </a:rPr>
+              <a:t>+₹50 cr NPV at 15% → IRR ≈ 21.3% → accept, in stages</a:t>
+            </a:r>
+          </a:p>
+        </p:txBody>
+      </p:sp>
+      <p:sp>
+        <p:nvSpPr>
+          <p:cNvPr id="70" name="Rounded Rectangle 69"/>
+          <p:cNvSpPr/>
+          <p:nvPr/>
+        </p:nvSpPr>
+        <p:spPr>
+          <a:xfrm>
+            <a:off x="7059168" y="5300847"/>
+            <a:ext cx="4474159" cy="914400"/>
           </a:xfrm>
           <a:prstGeom prst="roundRect">
             <a:avLst>
@@ -21416,14 +22414,14 @@
       </p:sp>
       <p:sp>
         <p:nvSpPr>
-          <p:cNvPr id="59" name="TextBox 58"/>
-          <p:cNvSpPr txBox="1"/>
-          <p:nvPr/>
-        </p:nvSpPr>
-        <p:spPr>
-          <a:xfrm>
-            <a:off x="7242048" y="4089913"/>
-            <a:ext cx="4108399" cy="713232"/>
+          <p:cNvPr id="71" name="TextBox 70"/>
+          <p:cNvSpPr txBox="1"/>
+          <p:nvPr/>
+        </p:nvSpPr>
+        <p:spPr>
+          <a:xfrm>
+            <a:off x="7223760" y="5300847"/>
+            <a:ext cx="4144975" cy="914400"/>
           </a:xfrm>
           <a:prstGeom prst="rect">
             <a:avLst/>
@@ -21442,7 +22440,7 @@
               </a:lnSpc>
             </a:pPr>
             <a:r>
-              <a:rPr sz="720" b="1" i="0" spc="100">
+              <a:rPr sz="700" b="1" i="0" spc="100">
                 <a:solidFill>
                   <a:srgbClr val="2B6CB0"/>
                 </a:solidFill>
@@ -21454,177 +22452,27 @@
           <a:p>
             <a:pPr algn="l">
               <a:lnSpc>
-                <a:spcPct val="128000"/>
+                <a:spcPct val="130000"/>
               </a:lnSpc>
               <a:spcBef>
                 <a:spcPts val="400"/>
               </a:spcBef>
             </a:pPr>
             <a:r>
-              <a:rPr sz="840" b="0" i="0">
+              <a:rPr sz="819" b="0" i="0">
                 <a:solidFill>
                   <a:srgbClr val="44546A"/>
                 </a:solidFill>
                 <a:latin typeface="Calibri"/>
               </a:rPr>
               <a:t>Market shares are FY25 VAHAN-based industry estimates, used to establish the market structure — not to forecast our own volumes. The IRR is illustrative, since the brief supplies only the NPV at 15%.</a:t>
-            </a:r>
-          </a:p>
-        </p:txBody>
-      </p:sp>
-      <p:sp>
-        <p:nvSpPr>
-          <p:cNvPr id="60" name="Rounded Rectangle 59"/>
-          <p:cNvSpPr/>
-          <p:nvPr/>
-        </p:nvSpPr>
-        <p:spPr>
-          <a:xfrm>
-            <a:off x="658368" y="5138928"/>
-            <a:ext cx="5760720" cy="786384"/>
-          </a:xfrm>
-          <a:prstGeom prst="roundRect">
-            <a:avLst>
-              <a:gd name="adj" fmla="val 4000"/>
-            </a:avLst>
-          </a:prstGeom>
-          <a:solidFill>
-            <a:srgbClr val="ECF2FA"/>
-          </a:solidFill>
-          <a:ln w="7620">
-            <a:solidFill>
-              <a:srgbClr val="C9DCF0"/>
-            </a:solidFill>
-          </a:ln>
-          <a:effectLst/>
-        </p:spPr>
-        <p:style>
-          <a:lnRef idx="1">
-            <a:schemeClr val="accent1"/>
-          </a:lnRef>
-          <a:fillRef idx="3">
-            <a:schemeClr val="accent1"/>
-          </a:fillRef>
-          <a:effectRef idx="2">
-            <a:schemeClr val="accent1"/>
-          </a:effectRef>
-          <a:fontRef idx="minor">
-            <a:schemeClr val="lt1"/>
-          </a:fontRef>
-        </p:style>
-        <p:txBody>
-          <a:bodyPr rtlCol="0" anchor="ctr" wrap="square"/>
-          <a:lstStyle/>
-          <a:p>
-            <a:pPr algn="ctr"/>
-          </a:p>
-        </p:txBody>
-      </p:sp>
-      <p:sp>
-        <p:nvSpPr>
-          <p:cNvPr id="61" name="Rectangle 60"/>
-          <p:cNvSpPr/>
-          <p:nvPr/>
-        </p:nvSpPr>
-        <p:spPr>
-          <a:xfrm>
-            <a:off x="658368" y="5138928"/>
-            <a:ext cx="45720" cy="786384"/>
-          </a:xfrm>
-          <a:prstGeom prst="rect">
-            <a:avLst/>
-          </a:prstGeom>
-          <a:solidFill>
-            <a:srgbClr val="2B6CB0"/>
-          </a:solidFill>
-          <a:ln>
-            <a:noFill/>
-          </a:ln>
-          <a:effectLst/>
-        </p:spPr>
-        <p:style>
-          <a:lnRef idx="1">
-            <a:schemeClr val="accent1"/>
-          </a:lnRef>
-          <a:fillRef idx="3">
-            <a:schemeClr val="accent1"/>
-          </a:fillRef>
-          <a:effectRef idx="2">
-            <a:schemeClr val="accent1"/>
-          </a:effectRef>
-          <a:fontRef idx="minor">
-            <a:schemeClr val="lt1"/>
-          </a:fontRef>
-        </p:style>
-        <p:txBody>
-          <a:bodyPr rtlCol="0" anchor="ctr" wrap="square"/>
-          <a:lstStyle/>
-          <a:p>
-            <a:pPr algn="ctr"/>
-          </a:p>
-        </p:txBody>
-      </p:sp>
-      <p:sp>
-        <p:nvSpPr>
-          <p:cNvPr id="62" name="TextBox 61"/>
-          <p:cNvSpPr txBox="1"/>
-          <p:nvPr/>
-        </p:nvSpPr>
-        <p:spPr>
-          <a:xfrm>
-            <a:off x="859536" y="5248656"/>
-            <a:ext cx="5358384" cy="566928"/>
-          </a:xfrm>
-          <a:prstGeom prst="rect">
-            <a:avLst/>
-          </a:prstGeom>
-          <a:noFill/>
-        </p:spPr>
-        <p:txBody>
-          <a:bodyPr wrap="square" lIns="0" rIns="0" tIns="0" bIns="0" anchor="t">
-            <a:noAutofit/>
-          </a:bodyPr>
-          <a:lstStyle/>
-          <a:p>
-            <a:pPr algn="l">
-              <a:lnSpc>
-                <a:spcPct val="100000"/>
-              </a:lnSpc>
-            </a:pPr>
-            <a:r>
-              <a:rPr sz="720" b="1" i="0" spc="100">
-                <a:solidFill>
-                  <a:srgbClr val="2B6CB0"/>
-                </a:solidFill>
-                <a:latin typeface="Calibri"/>
-              </a:rPr>
-              <a:t>DECLARATION</a:t>
-            </a:r>
-          </a:p>
-          <a:p>
-            <a:pPr algn="l">
-              <a:lnSpc>
-                <a:spcPct val="126000"/>
-              </a:lnSpc>
-              <a:spcBef>
-                <a:spcPts val="400"/>
-              </a:spcBef>
-            </a:pPr>
-            <a:r>
-              <a:rPr sz="840" b="0" i="0">
-                <a:solidFill>
-                  <a:srgbClr val="44546A"/>
-                </a:solidFill>
-                <a:latin typeface="Calibri"/>
-              </a:rPr>
-              <a:t>This assignment is my own work, prepared from the recorded sessions and the case brief, and is submitted on or before the deadline set in Google Classroom.</a:t>
             </a:r>
           </a:p>
         </p:txBody>
       </p:sp>
       <p:cxnSp>
         <p:nvCxnSpPr>
-          <p:cNvPr id="63" name="Connector 62"/>
+          <p:cNvPr id="72" name="Connector 71"/>
           <p:cNvCxnSpPr/>
           <p:nvPr/>
         </p:nvCxnSpPr>
@@ -21659,7 +22507,7 @@
       </p:cxnSp>
       <p:sp>
         <p:nvSpPr>
-          <p:cNvPr id="64" name="TextBox 63"/>
+          <p:cNvPr id="73" name="TextBox 72"/>
           <p:cNvSpPr txBox="1"/>
           <p:nvPr/>
         </p:nvSpPr>
@@ -21698,7 +22546,7 @@
       </p:sp>
       <p:sp>
         <p:nvSpPr>
-          <p:cNvPr id="65" name="TextBox 64"/>
+          <p:cNvPr id="74" name="TextBox 73"/>
           <p:cNvSpPr txBox="1"/>
           <p:nvPr/>
         </p:nvSpPr>
@@ -21737,7 +22585,7 @@
       </p:sp>
       <p:sp>
         <p:nvSpPr>
-          <p:cNvPr id="66" name="TextBox 65"/>
+          <p:cNvPr id="75" name="TextBox 74"/>
           <p:cNvSpPr txBox="1"/>
           <p:nvPr/>
         </p:nvSpPr>
@@ -21776,7 +22624,7 @@
       </p:sp>
       <p:sp>
         <p:nvSpPr>
-          <p:cNvPr id="67" name="TextBox 66"/>
+          <p:cNvPr id="76" name="TextBox 75"/>
           <p:cNvSpPr txBox="1"/>
           <p:nvPr/>
         </p:nvSpPr>

</xml_diff>

<commit_message>
Appendix B: convert data note to footnote, align cards, refresh preview
Co-authored-by: arena-agent <297053741+arena-agent@users.noreply.github.com>
</commit_message>
<xml_diff>
--- a/Zenith-V_Launch_Decision_JGaneshKumarReddy_23BDS024.pptx
+++ b/Zenith-V_Launch_Decision_JGaneshKumarReddy_23BDS024.pptx
@@ -22364,54 +22364,41 @@
           </a:p>
         </p:txBody>
       </p:sp>
-      <p:sp>
-        <p:nvSpPr>
-          <p:cNvPr id="70" name="Rounded Rectangle 69"/>
-          <p:cNvSpPr/>
-          <p:nvPr/>
-        </p:nvSpPr>
-        <p:spPr>
-          <a:xfrm>
-            <a:off x="7059168" y="5300847"/>
-            <a:ext cx="4474159" cy="914400"/>
-          </a:xfrm>
-          <a:prstGeom prst="roundRect">
-            <a:avLst>
-              <a:gd name="adj" fmla="val 4000"/>
-            </a:avLst>
-          </a:prstGeom>
-          <a:solidFill>
-            <a:srgbClr val="F7F9FC"/>
-          </a:solidFill>
+      <p:cxnSp>
+        <p:nvCxnSpPr>
+          <p:cNvPr id="70" name="Connector 69"/>
+          <p:cNvCxnSpPr/>
+          <p:nvPr/>
+        </p:nvCxnSpPr>
+        <p:spPr>
+          <a:xfrm>
+            <a:off x="7059168" y="5282559"/>
+            <a:ext cx="4474159" cy="0"/>
+          </a:xfrm>
+          <a:prstGeom prst="line">
+            <a:avLst/>
+          </a:prstGeom>
           <a:ln w="7620">
             <a:solidFill>
               <a:srgbClr val="DCE3EC"/>
             </a:solidFill>
           </a:ln>
-          <a:effectLst/>
         </p:spPr>
         <p:style>
-          <a:lnRef idx="1">
+          <a:lnRef idx="2">
             <a:schemeClr val="accent1"/>
           </a:lnRef>
-          <a:fillRef idx="3">
+          <a:fillRef idx="0">
             <a:schemeClr val="accent1"/>
           </a:fillRef>
-          <a:effectRef idx="2">
+          <a:effectRef idx="1">
             <a:schemeClr val="accent1"/>
           </a:effectRef>
           <a:fontRef idx="minor">
-            <a:schemeClr val="lt1"/>
+            <a:schemeClr val="tx1"/>
           </a:fontRef>
         </p:style>
-        <p:txBody>
-          <a:bodyPr rtlCol="0" anchor="ctr" wrap="square"/>
-          <a:lstStyle/>
-          <a:p>
-            <a:pPr algn="ctr"/>
-          </a:p>
-        </p:txBody>
-      </p:sp>
+      </p:cxnSp>
       <p:sp>
         <p:nvSpPr>
           <p:cNvPr id="71" name="TextBox 70"/>
@@ -22420,52 +22407,33 @@
         </p:nvSpPr>
         <p:spPr>
           <a:xfrm>
-            <a:off x="7223760" y="5300847"/>
-            <a:ext cx="4144975" cy="914400"/>
-          </a:xfrm>
-          <a:prstGeom prst="rect">
-            <a:avLst/>
-          </a:prstGeom>
-          <a:noFill/>
-        </p:spPr>
-        <p:txBody>
-          <a:bodyPr wrap="square" lIns="0" rIns="0" tIns="0" bIns="0" anchor="t">
-            <a:noAutofit/>
-          </a:bodyPr>
-          <a:lstStyle/>
-          <a:p>
-            <a:pPr algn="l">
-              <a:lnSpc>
-                <a:spcPct val="100000"/>
-              </a:lnSpc>
-            </a:pPr>
-            <a:r>
-              <a:rPr sz="700" b="1" i="0" spc="100">
-                <a:solidFill>
-                  <a:srgbClr val="2B6CB0"/>
-                </a:solidFill>
-                <a:latin typeface="Calibri"/>
-              </a:rPr>
-              <a:t>NOTE ON THE DATA</a:t>
-            </a:r>
-          </a:p>
+            <a:off x="7059168" y="5392287"/>
+            <a:ext cx="4474159" cy="566928"/>
+          </a:xfrm>
+          <a:prstGeom prst="rect">
+            <a:avLst/>
+          </a:prstGeom>
+          <a:noFill/>
+        </p:spPr>
+        <p:txBody>
+          <a:bodyPr wrap="square" lIns="0" rIns="0" tIns="0" bIns="0" anchor="t">
+            <a:noAutofit/>
+          </a:bodyPr>
+          <a:lstStyle/>
           <a:p>
             <a:pPr algn="l">
               <a:lnSpc>
                 <a:spcPct val="130000"/>
               </a:lnSpc>
-              <a:spcBef>
-                <a:spcPts val="400"/>
-              </a:spcBef>
-            </a:pPr>
-            <a:r>
-              <a:rPr sz="819" b="0" i="0">
-                <a:solidFill>
-                  <a:srgbClr val="44546A"/>
-                </a:solidFill>
-                <a:latin typeface="Calibri"/>
-              </a:rPr>
-              <a:t>Market shares are FY25 VAHAN-based industry estimates, used to establish the market structure — not to forecast our own volumes. The IRR is illustrative, since the brief supplies only the NPV at 15%.</a:t>
+            </a:pPr>
+            <a:r>
+              <a:rPr sz="800" b="0" i="0">
+                <a:solidFill>
+                  <a:srgbClr val="7B8B9E"/>
+                </a:solidFill>
+                <a:latin typeface="Calibri"/>
+              </a:rPr>
+              <a:t>Note: market shares are FY25 VAHAN-based industry estimates, used to establish the market structure — not to forecast our own volumes. The IRR is illustrative, since the brief supplies only the NPV at 15%.</a:t>
             </a:r>
           </a:p>
         </p:txBody>

</xml_diff>

<commit_message>
Student-ready polish: brief slide titles, link tooltips, image alt text, chart label fix
Co-authored-by: arena-agent <297053741+arena-agent@users.noreply.github.com>
</commit_message>
<xml_diff>
--- a/Zenith-V_Launch_Decision_JGaneshKumarReddy_23BDS024.pptx
+++ b/Zenith-V_Launch_Decision_JGaneshKumarReddy_23BDS024.pptx
@@ -513,6 +513,12 @@
               <a:t>Good morning. This is my case-study presentation on the Zenith-V, the electric scooter that E-Mobility India plans to launch. The brief asks three questions: what kind of market we are entering, what we should charge, and whether the Chennai plant is worth ₹200 crore. I have drawn the concepts from Sessions 5 to 9 of the Managerial Economics course.</a:t>
             </a:r>
           </a:p>
+          <a:p/>
+          <a:p>
+            <a:r>
+              <a:t>Sessions covered: 5 Pricing Strategies, 6 Profit, 7 Game Theory, 8 Risk, 9 Capital Budgeting.</a:t>
+            </a:r>
+          </a:p>
         </p:txBody>
       </p:sp>
       <p:sp>
@@ -583,6 +589,12 @@
               <a:t>An oligopoly has four recognisable features and this market shows all four. First, few sellers: Ola, TVS, Bajaj and Ather take 86% of FY25 registrations, giving an HHI of about 1,900. Second, strategic interdependence — every price decision is taken after predicting rivals' reactions. Third, barriers to entry: ₹200 crore of plant and thousands of service points. Fourth, price rigidity, with competition shifting to range, warranty and software.</a:t>
             </a:r>
           </a:p>
+          <a:p/>
+          <a:p>
+            <a:r>
+              <a:t>Source: Session 7 – Game Theory — https://youtu.be/f91JEkm7XZg</a:t>
+            </a:r>
+          </a:p>
         </p:txBody>
       </p:sp>
       <p:sp>
@@ -653,6 +665,12 @@
               <a:t>Petrol is a complement to a petrol scooter, so when it becomes expensive the total cost of the petrol option rises and demand for the electric substitute rises. That is cross-price elasticity, and it is positive. Our own price has not changed, so this is a rightward shift of the demand curve, not movement along it. In money terms the customer saves about ₹3,840 a month, roughly ₹46,000 a year.</a:t>
             </a:r>
           </a:p>
+          <a:p/>
+          <a:p>
+            <a:r>
+              <a:t>Source: Session 5 – Pricing Strategies — https://youtu.be/T25QYasiVrM</a:t>
+            </a:r>
+          </a:p>
         </p:txBody>
       </p:sp>
       <p:sp>
@@ -723,6 +741,12 @@
               <a:t>The brief frames this as market share versus recovering R&amp;D, but at ₹74,999 we still make ₹14,999 a scooter, a 25% mark-up — so penetration is not loss-leading. Demand is elastic, so price moves revenue; and the experience curve means today's volume lowers tomorrow's cost. Skimming only works when demand is inelastic and imitation is slow, and neither holds with four rivals sitting on idle capacity.</a:t>
             </a:r>
           </a:p>
+          <a:p/>
+          <a:p>
+            <a:r>
+              <a:t>Source: Sessions 5 &amp; 6 – Pricing Strategies, Profit — https://youtu.be/T25QYasiVrM  ·  https://youtu.be/d7Qw3Bu-23E</a:t>
+            </a:r>
+          </a:p>
         </p:txBody>
       </p:sp>
       <p:sp>
@@ -793,6 +817,12 @@
               <a:t>This slide is the core of strategic interdependence. Penetration is our dominant strategy, and matching is the rivals' best reply, so the outcome is the Nash equilibrium (25, 30), even though both firms would prefer the (28, 35) truce. That truce is not credible. Ola will match first; Ather will defend its premium niche rather than chase us down; TVS and Bajaj will respond through finance and exchange offers.</a:t>
             </a:r>
           </a:p>
+          <a:p/>
+          <a:p>
+            <a:r>
+              <a:t>Source: Session 7 – Game Theory — https://youtu.be/f91JEkm7XZg</a:t>
+            </a:r>
+          </a:p>
         </p:txBody>
       </p:sp>
       <p:sp>
@@ -863,6 +893,12 @@
               <a:t>The NPV result does most of the work. At 15% the project is worth ₹50 crore more than it costs, so the present value of inflows is ₹250 crore and the profitability index is 1.25. Because NPV falls as the discount rate rises, a positive NPV at 15% proves that the IRR is above 15%; on level cash flows of ₹49.8 crore for ten years it is about 21.3%. On risk: many inputs are measurable risks, but the big ones — a battery breakthrough or a subsidy redesign — are genuine uncertainty, which is the argument for staging the investment.</a:t>
             </a:r>
           </a:p>
+          <a:p/>
+          <a:p>
+            <a:r>
+              <a:t>Source: Sessions 8 &amp; 9 – Risk, Capital Budgeting — https://youtu.be/LsGQdSKB80o  ·  https://youtu.be/Y_NwyfpzUIo</a:t>
+            </a:r>
+          </a:p>
         </p:txBody>
       </p:sp>
       <p:sp>
@@ -933,6 +969,12 @@
               <a:t>So the recommendation has three parts. Enter as a differentiated, scale-led challenger in an oligopoly. Launch at ₹74,999 with a premium trim above it. Accept the project, since IRR of roughly 21.3% clears the 15% hurdle, but release the ₹200 crore in three gates with written exit rules.</a:t>
             </a:r>
           </a:p>
+          <a:p/>
+          <a:p>
+            <a:r>
+              <a:t>All sessions: 5, 6, 7, 8 and 9 of Managerial Economics.</a:t>
+            </a:r>
+          </a:p>
         </p:txBody>
       </p:sp>
       <p:sp>
@@ -1003,6 +1045,12 @@
               <a:t>Appendix A lists every input and every derived figure so the analysis can be re-run. The IRR is illustrative: the brief gives only the NPV at 15%, so I assumed level cash flows to show what an IRR of about 21% implies.</a:t>
             </a:r>
           </a:p>
+          <a:p/>
+          <a:p>
+            <a:r>
+              <a:t>Appendix A — every assumption used in the deck, with its source.</a:t>
+            </a:r>
+          </a:p>
         </p:txBody>
       </p:sp>
       <p:sp>
@@ -1071,6 +1119,12 @@
           <a:p>
             <a:r>
               <a:t>Appendix B records the recorded sessions I used and maps the deck to the marking rubric, so each component — market analysis, pricing and game theory, and capital budgeting — can be traced to specific slides.</a:t>
+            </a:r>
+          </a:p>
+          <a:p/>
+          <a:p>
+            <a:r>
+              <a:t>Appendix B — recorded sessions with links, and the rubric map.</a:t>
             </a:r>
           </a:p>
         </p:txBody>
@@ -4253,7 +4307,7 @@
       </p:sp>
       <p:pic>
         <p:nvPicPr>
-          <p:cNvPr id="6" name="Picture 5" descr="hero_card.png"/>
+          <p:cNvPr id="6" name="Picture 5" descr="The Zenith-V electric scooter — product image used on the title slide"/>
           <p:cNvPicPr>
             <a:picLocks noChangeAspect="1"/>
           </p:cNvPicPr>
@@ -4816,7 +4870,7 @@
                   <a:srgbClr val="12263F"/>
                 </a:solidFill>
                 <a:latin typeface="Calibri"/>
-                <a:hlinkClick r:id="rId3"/>
+                <a:hlinkClick r:id="rId3" tooltip="Watch Session 5 — Pricing Strategies"/>
               </a:rPr>
               <a:t>Session 5</a:t>
             </a:r>
@@ -4856,7 +4910,7 @@
                   <a:srgbClr val="44546A"/>
                 </a:solidFill>
                 <a:latin typeface="Calibri"/>
-                <a:hlinkClick r:id="rId3"/>
+                <a:hlinkClick r:id="rId3" tooltip="Watch Session 5 — Pricing Strategies"/>
               </a:rPr>
               <a:t>Pricing Strategies</a:t>
             </a:r>
@@ -4935,7 +4989,7 @@
                   <a:srgbClr val="12263F"/>
                 </a:solidFill>
                 <a:latin typeface="Calibri"/>
-                <a:hlinkClick r:id="rId4"/>
+                <a:hlinkClick r:id="rId4" tooltip="Watch Session 6 — Profit"/>
               </a:rPr>
               <a:t>Session 6</a:t>
             </a:r>
@@ -4975,7 +5029,7 @@
                   <a:srgbClr val="44546A"/>
                 </a:solidFill>
                 <a:latin typeface="Calibri"/>
-                <a:hlinkClick r:id="rId4"/>
+                <a:hlinkClick r:id="rId4" tooltip="Watch Session 6 — Profit"/>
               </a:rPr>
               <a:t>Profit</a:t>
             </a:r>
@@ -5054,7 +5108,7 @@
                   <a:srgbClr val="12263F"/>
                 </a:solidFill>
                 <a:latin typeface="Calibri"/>
-                <a:hlinkClick r:id="rId5"/>
+                <a:hlinkClick r:id="rId5" tooltip="Watch Session 7 — Game Theory"/>
               </a:rPr>
               <a:t>Session 7</a:t>
             </a:r>
@@ -5094,7 +5148,7 @@
                   <a:srgbClr val="44546A"/>
                 </a:solidFill>
                 <a:latin typeface="Calibri"/>
-                <a:hlinkClick r:id="rId5"/>
+                <a:hlinkClick r:id="rId5" tooltip="Watch Session 7 — Game Theory"/>
               </a:rPr>
               <a:t>Game Theory</a:t>
             </a:r>
@@ -5173,7 +5227,7 @@
                   <a:srgbClr val="12263F"/>
                 </a:solidFill>
                 <a:latin typeface="Calibri"/>
-                <a:hlinkClick r:id="rId6"/>
+                <a:hlinkClick r:id="rId6" tooltip="Watch Session 8 — Risk"/>
               </a:rPr>
               <a:t>Session 8</a:t>
             </a:r>
@@ -5213,7 +5267,7 @@
                   <a:srgbClr val="44546A"/>
                 </a:solidFill>
                 <a:latin typeface="Calibri"/>
-                <a:hlinkClick r:id="rId6"/>
+                <a:hlinkClick r:id="rId6" tooltip="Watch Session 8 — Risk"/>
               </a:rPr>
               <a:t>Risk</a:t>
             </a:r>
@@ -5292,7 +5346,7 @@
                   <a:srgbClr val="12263F"/>
                 </a:solidFill>
                 <a:latin typeface="Calibri"/>
-                <a:hlinkClick r:id="rId7"/>
+                <a:hlinkClick r:id="rId7" tooltip="Watch Session 9 — Capital Budgeting &amp; Fiscal Policy"/>
               </a:rPr>
               <a:t>Session 9</a:t>
             </a:r>
@@ -5332,7 +5386,7 @@
                   <a:srgbClr val="44546A"/>
                 </a:solidFill>
                 <a:latin typeface="Calibri"/>
-                <a:hlinkClick r:id="rId7"/>
+                <a:hlinkClick r:id="rId7" tooltip="Watch Session 9 — Capital Budgeting &amp; Fiscal Policy"/>
               </a:rPr>
               <a:t>Capital Budgeting &amp; Fiscal Policy</a:t>
             </a:r>
@@ -5347,33 +5401,42 @@
         </p:nvSpPr>
         <p:spPr>
           <a:xfrm>
-            <a:off x="658368" y="6053328"/>
-            <a:ext cx="10874959" cy="219456"/>
-          </a:xfrm>
-          <a:prstGeom prst="rect">
-            <a:avLst/>
-          </a:prstGeom>
-          <a:noFill/>
-        </p:spPr>
-        <p:txBody>
-          <a:bodyPr wrap="square" lIns="0" rIns="0" tIns="0" bIns="0" anchor="t">
-            <a:noAutofit/>
-          </a:bodyPr>
-          <a:lstStyle/>
-          <a:p>
-            <a:pPr algn="l">
-              <a:lnSpc>
-                <a:spcPct val="125000"/>
-              </a:lnSpc>
-            </a:pPr>
-            <a:r>
-              <a:rPr sz="880" b="0" i="0">
+            <a:off x="658368" y="5961888"/>
+            <a:ext cx="10874959" cy="274320"/>
+          </a:xfrm>
+          <a:prstGeom prst="rect">
+            <a:avLst/>
+          </a:prstGeom>
+          <a:noFill/>
+        </p:spPr>
+        <p:txBody>
+          <a:bodyPr wrap="square" lIns="0" rIns="0" tIns="0" bIns="0" anchor="t">
+            <a:noAutofit/>
+          </a:bodyPr>
+          <a:lstStyle/>
+          <a:p>
+            <a:pPr algn="l">
+              <a:lnSpc>
+                <a:spcPct val="130000"/>
+              </a:lnSpc>
+            </a:pPr>
+            <a:r>
+              <a:rPr sz="780" b="1" i="0" spc="120">
+                <a:solidFill>
+                  <a:srgbClr val="12263F"/>
+                </a:solidFill>
+                <a:latin typeface="Calibri"/>
+              </a:rPr>
+              <a:t>WHAT'S INSIDE   </a:t>
+            </a:r>
+            <a:r>
+              <a:rPr sz="840" b="0" i="0">
                 <a:solidFill>
                   <a:srgbClr val="7B8B9E"/>
                 </a:solidFill>
                 <a:latin typeface="Calibri"/>
               </a:rPr>
-              <a:t>This deck answers the three tasks in the assignment brief: market and demand analysis, pricing and game theory, and capital budgeting.</a:t>
+              <a:t>1 Title  ·  2 Market structure  ·  3 Demand &amp; elasticity  ·  4 Pricing strategy  ·  5 Rival response  ·  6 Capital budgeting  ·  7 Conclusion  ·  Appendix A–B</a:t>
             </a:r>
           </a:p>
         </p:txBody>
@@ -5665,7 +5728,7 @@
                 </a:solidFill>
                 <a:latin typeface="Calibri"/>
               </a:rPr>
-              <a:t>1 · MARKET &amp; DEMAND ANALYSIS</a:t>
+              <a:t>SLIDE 2 · MARKET STRUCTURE ANALYSIS</a:t>
             </a:r>
           </a:p>
         </p:txBody>
@@ -5703,7 +5766,7 @@
                   <a:srgbClr val="2B6CB0"/>
                 </a:solidFill>
                 <a:latin typeface="Calibri"/>
-                <a:hlinkClick r:id="rId2"/>
+                <a:hlinkClick r:id="rId2" tooltip="Open the recorded lecture session"/>
               </a:rPr>
               <a:t>LECTURE LINK · SESSION 7: GAME THEORY</a:t>
             </a:r>
@@ -6538,7 +6601,7 @@
       </p:sp>
       <p:pic>
         <p:nvPicPr>
-          <p:cNvPr id="26" name="Picture 25" descr="chart_market_share.png"/>
+          <p:cNvPr id="26" name="Picture 25" descr="Bar chart: FY25 electric two-wheeler market share — Ola 30.0%, TVS 21.4%, Bajaj 20.0%, Ather 11.6%, Hero 5.0%, others 8.0%"/>
           <p:cNvPicPr>
             <a:picLocks noChangeAspect="1"/>
           </p:cNvPicPr>
@@ -7120,7 +7183,7 @@
                 </a:solidFill>
                 <a:latin typeface="Calibri"/>
               </a:rPr>
-              <a:t>1 · MARKET &amp; DEMAND ANALYSIS</a:t>
+              <a:t>SLIDE 3 · DEMAND &amp; ELASTICITY ANALYSIS</a:t>
             </a:r>
           </a:p>
         </p:txBody>
@@ -7158,7 +7221,7 @@
                   <a:srgbClr val="2B6CB0"/>
                 </a:solidFill>
                 <a:latin typeface="Calibri"/>
-                <a:hlinkClick r:id="rId2"/>
+                <a:hlinkClick r:id="rId2" tooltip="Open the recorded lecture session"/>
               </a:rPr>
               <a:t>LECTURE LINK · SESSION 5: PRICING STRATEGIES</a:t>
             </a:r>
@@ -7280,7 +7343,7 @@
       </p:cxnSp>
       <p:pic>
         <p:nvPicPr>
-          <p:cNvPr id="8" name="Picture 7" descr="chart_demand_shift.png"/>
+          <p:cNvPr id="8" name="Picture 7" descr="Demand diagram: when petrol rises from 95 to 115 rupees a litre the demand curve for the Zenith-V shifts right, from D0 to D1"/>
           <p:cNvPicPr>
             <a:picLocks noChangeAspect="1"/>
           </p:cNvPicPr>
@@ -7645,7 +7708,25 @@
                 </a:solidFill>
                 <a:latin typeface="Calibri"/>
               </a:rPr>
-              <a:t>Exy &gt; 0</a:t>
+              <a:t>E</a:t>
+            </a:r>
+            <a:r>
+              <a:rPr sz="950" b="1" i="0" baseline="-25000">
+                <a:solidFill>
+                  <a:srgbClr val="12263F"/>
+                </a:solidFill>
+                <a:latin typeface="Calibri"/>
+              </a:rPr>
+              <a:t>xy</a:t>
+            </a:r>
+            <a:r>
+              <a:rPr sz="950" b="1" i="0">
+                <a:solidFill>
+                  <a:srgbClr val="12263F"/>
+                </a:solidFill>
+                <a:latin typeface="Calibri"/>
+              </a:rPr>
+              <a:t> &gt; 0</a:t>
             </a:r>
             <a:r>
               <a:rPr sz="950" b="0" i="0">
@@ -8336,7 +8417,7 @@
                 </a:solidFill>
                 <a:latin typeface="Calibri"/>
               </a:rPr>
-              <a:t>2 · PRICING &amp; GAME THEORY</a:t>
+              <a:t>SLIDE 4 · PRICING STRATEGY &amp; JUSTIFICATION</a:t>
             </a:r>
           </a:p>
         </p:txBody>
@@ -8374,7 +8455,7 @@
                   <a:srgbClr val="2B6CB0"/>
                 </a:solidFill>
                 <a:latin typeface="Calibri"/>
-                <a:hlinkClick r:id="rId2"/>
+                <a:hlinkClick r:id="rId2" tooltip="Open the recorded lecture session"/>
               </a:rPr>
               <a:t>LECTURE LINK · SESSION 5: PRICING STRATEGIES</a:t>
             </a:r>
@@ -8712,7 +8793,7 @@
                 </a:solidFill>
                 <a:latin typeface="Calibri"/>
               </a:rPr>
-              <a:t>PENETRATION   ←  RECOMMENDED</a:t>
+              <a:t>PENETRATION   ·   RECOMMENDED</a:t>
             </a:r>
           </a:p>
         </p:txBody>
@@ -10076,7 +10157,7 @@
       </p:sp>
       <p:pic>
         <p:nvPicPr>
-          <p:cNvPr id="46" name="Picture 45" descr="chart_price_tradeoff.png"/>
+          <p:cNvPr id="46" name="Picture 45" descr="Line chart: units needed to recover the 200 crore plant against launch price — 1.33 lakh units at 74,999 versus 0.40 lakh at 1,10,000"/>
           <p:cNvPicPr>
             <a:picLocks noChangeAspect="1"/>
           </p:cNvPicPr>
@@ -10928,7 +11009,7 @@
                 </a:solidFill>
                 <a:latin typeface="Calibri"/>
               </a:rPr>
-              <a:t>2 · PRICING &amp; GAME THEORY</a:t>
+              <a:t>SLIDE 5 · COMPETITOR RESPONSE &amp; INTERDEPENDENCE</a:t>
             </a:r>
           </a:p>
         </p:txBody>
@@ -10966,7 +11047,7 @@
                   <a:srgbClr val="2B6CB0"/>
                 </a:solidFill>
                 <a:latin typeface="Calibri"/>
-                <a:hlinkClick r:id="rId2"/>
+                <a:hlinkClick r:id="rId2" tooltip="Open the recorded lecture session"/>
               </a:rPr>
               <a:t>LECTURE LINK · SESSION 7: GAME THEORY</a:t>
             </a:r>
@@ -12719,7 +12800,7 @@
         <p:spPr>
           <a:xfrm>
             <a:off x="6729984" y="4486153"/>
-            <a:ext cx="4803343" cy="1274567"/>
+            <a:ext cx="4803343" cy="1091687"/>
           </a:xfrm>
           <a:prstGeom prst="roundRect">
             <a:avLst>
@@ -12853,7 +12934,7 @@
         </p:nvSpPr>
         <p:spPr>
           <a:xfrm>
-            <a:off x="6912864" y="5040584"/>
+            <a:off x="6912864" y="5068016"/>
             <a:ext cx="4437583" cy="165811"/>
           </a:xfrm>
           <a:prstGeom prst="rect">
@@ -12901,7 +12982,7 @@
         </p:nvSpPr>
         <p:spPr>
           <a:xfrm>
-            <a:off x="6912864" y="5284119"/>
+            <a:off x="6912864" y="5338983"/>
             <a:ext cx="4437583" cy="165811"/>
           </a:xfrm>
           <a:prstGeom prst="rect">
@@ -13366,7 +13447,7 @@
                 </a:solidFill>
                 <a:latin typeface="Calibri"/>
               </a:rPr>
-              <a:t>3 · CAPITAL BUDGETING</a:t>
+              <a:t>SLIDE 6 · CAPITAL BUDGETING ANALYSIS</a:t>
             </a:r>
           </a:p>
         </p:txBody>
@@ -13404,7 +13485,7 @@
                   <a:srgbClr val="2B6CB0"/>
                 </a:solidFill>
                 <a:latin typeface="Calibri"/>
-                <a:hlinkClick r:id="rId2"/>
+                <a:hlinkClick r:id="rId2" tooltip="Open the recorded lecture session"/>
               </a:rPr>
               <a:t>LECTURE LINK · SESSIONS 8 &amp; 9: RISK · CAPITAL BUDGETING</a:t>
             </a:r>
@@ -14414,7 +14495,7 @@
       </p:sp>
       <p:pic>
         <p:nvPicPr>
-          <p:cNvPr id="29" name="Picture 28" descr="chart_npv_profile.png"/>
+          <p:cNvPr id="29" name="Picture 28" descr="NPV profile: project NPV falls as the discount rate rises and crosses zero at an IRR of about 21.3 percent"/>
           <p:cNvPicPr>
             <a:picLocks noChangeAspect="1"/>
           </p:cNvPicPr>
@@ -15293,7 +15374,7 @@
                 </a:solidFill>
                 <a:latin typeface="Calibri"/>
               </a:rPr>
-              <a:t>4 · CONCLUSION</a:t>
+              <a:t>SLIDE 7 · FINAL RECOMMENDATION &amp; CONCLUSION</a:t>
             </a:r>
           </a:p>
         </p:txBody>
@@ -20038,7 +20119,7 @@
                   <a:srgbClr val="2B6CB0"/>
                 </a:solidFill>
                 <a:latin typeface="Calibri"/>
-                <a:hlinkClick r:id="rId2"/>
+                <a:hlinkClick r:id="rId2" tooltip="Watch Session 5 — Pricing Strategies"/>
               </a:rPr>
               <a:t>https://youtu.be/T25QYasiVrM</a:t>
             </a:r>
@@ -20230,7 +20311,7 @@
                   <a:srgbClr val="2B6CB0"/>
                 </a:solidFill>
                 <a:latin typeface="Calibri"/>
-                <a:hlinkClick r:id="rId3"/>
+                <a:hlinkClick r:id="rId3" tooltip="Watch Session 6 — Profit"/>
               </a:rPr>
               <a:t>https://youtu.be/d7Qw3Bu-23E</a:t>
             </a:r>
@@ -20422,7 +20503,7 @@
                   <a:srgbClr val="2B6CB0"/>
                 </a:solidFill>
                 <a:latin typeface="Calibri"/>
-                <a:hlinkClick r:id="rId4"/>
+                <a:hlinkClick r:id="rId4" tooltip="Watch Session 7 — Game Theory"/>
               </a:rPr>
               <a:t>https://youtu.be/f91JEkm7XZg</a:t>
             </a:r>
@@ -20614,7 +20695,7 @@
                   <a:srgbClr val="2B6CB0"/>
                 </a:solidFill>
                 <a:latin typeface="Calibri"/>
-                <a:hlinkClick r:id="rId5"/>
+                <a:hlinkClick r:id="rId5" tooltip="Watch Session 8 — Risk"/>
               </a:rPr>
               <a:t>https://youtu.be/LsGQdSKB80o</a:t>
             </a:r>
@@ -20806,7 +20887,7 @@
                   <a:srgbClr val="2B6CB0"/>
                 </a:solidFill>
                 <a:latin typeface="Calibri"/>
-                <a:hlinkClick r:id="rId6"/>
+                <a:hlinkClick r:id="rId6" tooltip="Watch Session 9 — Capital Budgeting &amp; Fiscal Policy"/>
               </a:rPr>
               <a:t>https://youtu.be/Y_NwyfpzUIo</a:t>
             </a:r>

</xml_diff>